<commit_message>
Sim-Review VA06: 8 VPs umgesetzt + Artefakte neu + sim_review ✅
Co-Authored-By: Claude Fable 5 <noreply@anthropic.com>
</commit_message>
<xml_diff>
--- a/protected-downloads/praesentation/VA06.pptx
+++ b/protected-downloads/praesentation/VA06.pptx
@@ -5514,7 +5514,7 @@
                 </a:solidFill>
                 <a:latin typeface="Consolas"/>
               </a:rPr>
-              <a:t>00:50–01:05 </a:t>
+              <a:t>00:50–01:10 </a:t>
             </a:r>
             <a:r>
               <a:rPr sz="1500" b="1">
@@ -5551,7 +5551,7 @@
                 </a:solidFill>
                 <a:latin typeface="Consolas"/>
               </a:rPr>
-              <a:t>01:05–01:15 </a:t>
+              <a:t>01:10–01:15 </a:t>
             </a:r>
             <a:r>
               <a:rPr sz="1500" b="1">

</xml_diff>

<commit_message>
Welle 3: VA06 kuratiertes Deck + Terminmappe-Schaubild (Web/Admin/Workbook)
Co-Authored-By: Claude Fable 5 <noreply@anthropic.com>
</commit_message>
<xml_diff>
--- a/protected-downloads/praesentation/VA06.pptx
+++ b/protected-downloads/praesentation/VA06.pptx
@@ -12,6 +12,14 @@
     <p:sldId id="260" r:id="rId12"/>
     <p:sldId id="261" r:id="rId13"/>
     <p:sldId id="262" r:id="rId14"/>
+    <p:sldId id="263" r:id="rId15"/>
+    <p:sldId id="264" r:id="rId16"/>
+    <p:sldId id="265" r:id="rId17"/>
+    <p:sldId id="266" r:id="rId18"/>
+    <p:sldId id="267" r:id="rId19"/>
+    <p:sldId id="268" r:id="rId20"/>
+    <p:sldId id="269" r:id="rId21"/>
+    <p:sldId id="270" r:id="rId22"/>
   </p:sldIdLst>
   <p:sldSz cx="12188952" cy="6858000" type="screen4x3"/>
   <p:notesSz cx="6858000" cy="9144000"/>
@@ -578,7 +586,7 @@
           <a:lstStyle/>
           <a:p>
             <a:r>
-              <a:t>Siehe Trainerhandbuch (Sektion 3) für Moderationshinweise, Timing und erwartete Teilnehmerreaktionen.</a:t>
+              <a:t>Kernfrage: „Was braucht der Berater zur Entscheidung?" – nicht „Was gibt es alles?" Regieanweisung: Weglassen ist eine Leistung. Ein Berater mit zehn Minuten liest eine Seite, nicht zehn.</a:t>
             </a:r>
           </a:p>
         </p:txBody>
@@ -648,22 +656,7 @@
           <a:lstStyle/>
           <a:p>
             <a:r>
-              <a:t>AB-2 Musterlösung (Trainer-Version)</a:t>
-            </a:r>
-          </a:p>
-          <a:p>
-            <a:r>
-              <a:t>Eine gute Mappe enthält: Kurzprofil; Engagementübersicht mit der zu 95 % ausgelasteten Betriebsmittellinie prominent; aktuelle Kennzahlen (mit Hinweis auf die fehlende BWA als offener Punkt); als Anlässe markiert: Linienauslastung (Erhöhung?), auslaufende Zinsbindung (Prolongation), angedeutete Investition (Finanzierung); Agenda-Vorschlag mit diesen Punkten. Nachbereitung: drei Aufgaben mit Wiedervorlage und Systemdokumentation.</a:t>
-            </a:r>
-          </a:p>
-          <a:p>
-            <a:r>
-              <a:t>Kernbefund: Stärke der Mappe ist die Verdichtung und das aktive Markieren der Anlässe – der Berater muss sie nicht selbst aus den Daten suchen. Genau das ist Entlastung.</a:t>
-            </a:r>
-          </a:p>
-          <a:p>
-            <a:r>
-              <a:t>Trainer-Hinweis: Häufiger Fehler ist „viel hilft viel" – die Mappe wird zum Datenfriedhof. Loben Sie Weglassen. Die Anlass-Markierung ist die Brücke zu VA09 (Vertriebsanlässe aufbereiten).</a:t>
+              <a:t>Aus Kundensicht entsteht so Servicequalität: der Berater wirkt zuverlässig und kompetent, weil er Zahlen und Historie parat hat (SERVQUAL).</a:t>
             </a:r>
           </a:p>
         </p:txBody>
@@ -733,7 +726,367 @@
           <a:lstStyle/>
           <a:p>
             <a:r>
-              <a:t>Siehe Trainerhandbuch (Sektion 3) für Moderationshinweise, Timing und erwartete Teilnehmerreaktionen.</a:t>
+              <a:t>Zentrale Botschaft: Stärke = aktive Anlass-Markierung. Eine Andeutung ist kein schwacher Anlass – oft der wertvollste.</a:t>
+            </a:r>
+          </a:p>
+        </p:txBody>
+      </p:sp>
+      <p:sp>
+        <p:nvSpPr>
+          <p:cNvPr id="4" name="Slide Number Placeholder 3"/>
+          <p:cNvSpPr>
+            <a:spLocks noGrp="1"/>
+          </p:cNvSpPr>
+          <p:nvPr>
+            <p:ph type="sldNum" idx="5" sz="quarter"/>
+          </p:nvPr>
+        </p:nvSpPr>
+        <p:spPr/>
+      </p:sp>
+    </p:spTree>
+  </p:cSld>
+  <p:clrMapOvr>
+    <a:masterClrMapping/>
+  </p:clrMapOvr>
+</p:notes>
+</file>
+
+<file path=ppt/notesSlides/notesSlide5.xml><?xml version="1.0" encoding="utf-8"?>
+<p:notes xmlns:a="http://schemas.openxmlformats.org/drawingml/2006/main" xmlns:p="http://schemas.openxmlformats.org/presentationml/2006/main" xmlns:r="http://schemas.openxmlformats.org/officeDocument/2006/relationships">
+  <p:cSld>
+    <p:spTree>
+      <p:nvGrpSpPr>
+        <p:cNvPr id="1" name=""/>
+        <p:cNvGrpSpPr/>
+        <p:nvPr/>
+      </p:nvGrpSpPr>
+      <p:grpSpPr>
+        <a:xfrm>
+          <a:off x="0" y="0"/>
+          <a:ext cx="0" cy="0"/>
+          <a:chOff x="0" y="0"/>
+          <a:chExt cx="0" cy="0"/>
+        </a:xfrm>
+      </p:grpSpPr>
+      <p:sp>
+        <p:nvSpPr>
+          <p:cNvPr id="2" name="Slide Image Placeholder 1"/>
+          <p:cNvSpPr>
+            <a:spLocks noGrp="1"/>
+          </p:cNvSpPr>
+          <p:nvPr>
+            <p:ph type="sldImg" idx="2"/>
+          </p:nvPr>
+        </p:nvSpPr>
+        <p:spPr/>
+      </p:sp>
+      <p:sp>
+        <p:nvSpPr>
+          <p:cNvPr id="3" name="Notes Placeholder 2"/>
+          <p:cNvSpPr>
+            <a:spLocks noGrp="1"/>
+          </p:cNvSpPr>
+          <p:nvPr>
+            <p:ph type="body" idx="3" sz="quarter"/>
+          </p:nvPr>
+        </p:nvSpPr>
+        <p:spPr/>
+        <p:txBody>
+          <a:bodyPr/>
+          <a:lstStyle/>
+          <a:p>
+            <a:r>
+              <a:t>Beobachten, welche Auswahlentscheidungen die TN treffen. Kernfrage in der Besprechung: „Wer hat etwas bewusst weggelassen – und warum?"</a:t>
+            </a:r>
+          </a:p>
+        </p:txBody>
+      </p:sp>
+      <p:sp>
+        <p:nvSpPr>
+          <p:cNvPr id="4" name="Slide Number Placeholder 3"/>
+          <p:cNvSpPr>
+            <a:spLocks noGrp="1"/>
+          </p:cNvSpPr>
+          <p:nvPr>
+            <p:ph type="sldNum" idx="5" sz="quarter"/>
+          </p:nvPr>
+        </p:nvSpPr>
+        <p:spPr/>
+      </p:sp>
+    </p:spTree>
+  </p:cSld>
+  <p:clrMapOvr>
+    <a:masterClrMapping/>
+  </p:clrMapOvr>
+</p:notes>
+</file>
+
+<file path=ppt/notesSlides/notesSlide6.xml><?xml version="1.0" encoding="utf-8"?>
+<p:notes xmlns:a="http://schemas.openxmlformats.org/drawingml/2006/main" xmlns:p="http://schemas.openxmlformats.org/presentationml/2006/main" xmlns:r="http://schemas.openxmlformats.org/officeDocument/2006/relationships">
+  <p:cSld>
+    <p:spTree>
+      <p:nvGrpSpPr>
+        <p:cNvPr id="1" name=""/>
+        <p:cNvGrpSpPr/>
+        <p:nvPr/>
+      </p:nvGrpSpPr>
+      <p:grpSpPr>
+        <a:xfrm>
+          <a:off x="0" y="0"/>
+          <a:ext cx="0" cy="0"/>
+          <a:chOff x="0" y="0"/>
+          <a:chExt cx="0" cy="0"/>
+        </a:xfrm>
+      </p:grpSpPr>
+      <p:sp>
+        <p:nvSpPr>
+          <p:cNvPr id="2" name="Slide Image Placeholder 1"/>
+          <p:cNvSpPr>
+            <a:spLocks noGrp="1"/>
+          </p:cNvSpPr>
+          <p:nvPr>
+            <p:ph type="sldImg" idx="2"/>
+          </p:nvPr>
+        </p:nvSpPr>
+        <p:spPr/>
+      </p:sp>
+      <p:sp>
+        <p:nvSpPr>
+          <p:cNvPr id="3" name="Notes Placeholder 2"/>
+          <p:cNvSpPr>
+            <a:spLocks noGrp="1"/>
+          </p:cNvSpPr>
+          <p:nvPr>
+            <p:ph type="body" idx="3" sz="quarter"/>
+          </p:nvPr>
+        </p:nvSpPr>
+        <p:spPr/>
+        <p:txBody>
+          <a:bodyPr/>
+          <a:lstStyle/>
+          <a:p>
+            <a:r>
+              <a:t>Praxistipp Nachbereitung: realistische Fristen (10 Werktage statt 7 Kalendertage). Eskalationsweg mitdenken.</a:t>
+            </a:r>
+          </a:p>
+        </p:txBody>
+      </p:sp>
+      <p:sp>
+        <p:nvSpPr>
+          <p:cNvPr id="4" name="Slide Number Placeholder 3"/>
+          <p:cNvSpPr>
+            <a:spLocks noGrp="1"/>
+          </p:cNvSpPr>
+          <p:nvPr>
+            <p:ph type="sldNum" idx="5" sz="quarter"/>
+          </p:nvPr>
+        </p:nvSpPr>
+        <p:spPr/>
+      </p:sp>
+    </p:spTree>
+  </p:cSld>
+  <p:clrMapOvr>
+    <a:masterClrMapping/>
+  </p:clrMapOvr>
+</p:notes>
+</file>
+
+<file path=ppt/notesSlides/notesSlide7.xml><?xml version="1.0" encoding="utf-8"?>
+<p:notes xmlns:a="http://schemas.openxmlformats.org/drawingml/2006/main" xmlns:p="http://schemas.openxmlformats.org/presentationml/2006/main" xmlns:r="http://schemas.openxmlformats.org/officeDocument/2006/relationships">
+  <p:cSld>
+    <p:spTree>
+      <p:nvGrpSpPr>
+        <p:cNvPr id="1" name=""/>
+        <p:cNvGrpSpPr/>
+        <p:nvPr/>
+      </p:nvGrpSpPr>
+      <p:grpSpPr>
+        <a:xfrm>
+          <a:off x="0" y="0"/>
+          <a:ext cx="0" cy="0"/>
+          <a:chOff x="0" y="0"/>
+          <a:chExt cx="0" cy="0"/>
+        </a:xfrm>
+      </p:grpSpPr>
+      <p:sp>
+        <p:nvSpPr>
+          <p:cNvPr id="2" name="Slide Image Placeholder 1"/>
+          <p:cNvSpPr>
+            <a:spLocks noGrp="1"/>
+          </p:cNvSpPr>
+          <p:nvPr>
+            <p:ph type="sldImg" idx="2"/>
+          </p:nvPr>
+        </p:nvSpPr>
+        <p:spPr/>
+      </p:sp>
+      <p:sp>
+        <p:nvSpPr>
+          <p:cNvPr id="3" name="Notes Placeholder 2"/>
+          <p:cNvSpPr>
+            <a:spLocks noGrp="1"/>
+          </p:cNvSpPr>
+          <p:nvPr>
+            <p:ph type="body" idx="3" sz="quarter"/>
+          </p:nvPr>
+        </p:nvSpPr>
+        <p:spPr/>
+        <p:txBody>
+          <a:bodyPr/>
+          <a:lstStyle/>
+          <a:p>
+            <a:r>
+              <a:t>AB-2 Musterlösung (Trainer-Version)</a:t>
+            </a:r>
+          </a:p>
+          <a:p>
+            <a:r>
+              <a:t>Anlässe im Fall: Zinsbindung (Handlungsbedarf), 95 %-Auslastung (Kapazitätssignal), Investitionsandeutung (Kundensignal – am wichtigsten zu markieren), fehlende BWA (offener Punkt).</a:t>
+            </a:r>
+          </a:p>
+          <a:p>
+            <a:r>
+              <a:t>Trainer-Hinweis: Stärke zeigt sich im bewussten Weglassen und in der aktiven Anlass-Markierung, nicht in der Dicke der Mappe.</a:t>
+            </a:r>
+          </a:p>
+        </p:txBody>
+      </p:sp>
+      <p:sp>
+        <p:nvSpPr>
+          <p:cNvPr id="4" name="Slide Number Placeholder 3"/>
+          <p:cNvSpPr>
+            <a:spLocks noGrp="1"/>
+          </p:cNvSpPr>
+          <p:nvPr>
+            <p:ph type="sldNum" idx="5" sz="quarter"/>
+          </p:nvPr>
+        </p:nvSpPr>
+        <p:spPr/>
+      </p:sp>
+    </p:spTree>
+  </p:cSld>
+  <p:clrMapOvr>
+    <a:masterClrMapping/>
+  </p:clrMapOvr>
+</p:notes>
+</file>
+
+<file path=ppt/notesSlides/notesSlide8.xml><?xml version="1.0" encoding="utf-8"?>
+<p:notes xmlns:a="http://schemas.openxmlformats.org/drawingml/2006/main" xmlns:p="http://schemas.openxmlformats.org/presentationml/2006/main" xmlns:r="http://schemas.openxmlformats.org/officeDocument/2006/relationships">
+  <p:cSld>
+    <p:spTree>
+      <p:nvGrpSpPr>
+        <p:cNvPr id="1" name=""/>
+        <p:cNvGrpSpPr/>
+        <p:nvPr/>
+      </p:nvGrpSpPr>
+      <p:grpSpPr>
+        <a:xfrm>
+          <a:off x="0" y="0"/>
+          <a:ext cx="0" cy="0"/>
+          <a:chOff x="0" y="0"/>
+          <a:chExt cx="0" cy="0"/>
+        </a:xfrm>
+      </p:grpSpPr>
+      <p:sp>
+        <p:nvSpPr>
+          <p:cNvPr id="2" name="Slide Image Placeholder 1"/>
+          <p:cNvSpPr>
+            <a:spLocks noGrp="1"/>
+          </p:cNvSpPr>
+          <p:nvPr>
+            <p:ph type="sldImg" idx="2"/>
+          </p:nvPr>
+        </p:nvSpPr>
+        <p:spPr/>
+      </p:sp>
+      <p:sp>
+        <p:nvSpPr>
+          <p:cNvPr id="3" name="Notes Placeholder 2"/>
+          <p:cNvSpPr>
+            <a:spLocks noGrp="1"/>
+          </p:cNvSpPr>
+          <p:nvPr>
+            <p:ph type="body" idx="3" sz="quarter"/>
+          </p:nvPr>
+        </p:nvSpPr>
+        <p:spPr/>
+        <p:txBody>
+          <a:bodyPr/>
+          <a:lstStyle/>
+          <a:p>
+            <a:r>
+              <a:t>Drei Merksätze zum Abschluss: Verdichten – Anlässe markieren – nichts mündlich merken. Transfer-Anker: Sec 5.1, ersten realen Termin eintragen.</a:t>
+            </a:r>
+          </a:p>
+        </p:txBody>
+      </p:sp>
+      <p:sp>
+        <p:nvSpPr>
+          <p:cNvPr id="4" name="Slide Number Placeholder 3"/>
+          <p:cNvSpPr>
+            <a:spLocks noGrp="1"/>
+          </p:cNvSpPr>
+          <p:nvPr>
+            <p:ph type="sldNum" idx="5" sz="quarter"/>
+          </p:nvPr>
+        </p:nvSpPr>
+        <p:spPr/>
+      </p:sp>
+    </p:spTree>
+  </p:cSld>
+  <p:clrMapOvr>
+    <a:masterClrMapping/>
+  </p:clrMapOvr>
+</p:notes>
+</file>
+
+<file path=ppt/notesSlides/notesSlide9.xml><?xml version="1.0" encoding="utf-8"?>
+<p:notes xmlns:a="http://schemas.openxmlformats.org/drawingml/2006/main" xmlns:p="http://schemas.openxmlformats.org/presentationml/2006/main" xmlns:r="http://schemas.openxmlformats.org/officeDocument/2006/relationships">
+  <p:cSld>
+    <p:spTree>
+      <p:nvGrpSpPr>
+        <p:cNvPr id="1" name=""/>
+        <p:cNvGrpSpPr/>
+        <p:nvPr/>
+      </p:nvGrpSpPr>
+      <p:grpSpPr>
+        <a:xfrm>
+          <a:off x="0" y="0"/>
+          <a:ext cx="0" cy="0"/>
+          <a:chOff x="0" y="0"/>
+          <a:chExt cx="0" cy="0"/>
+        </a:xfrm>
+      </p:grpSpPr>
+      <p:sp>
+        <p:nvSpPr>
+          <p:cNvPr id="2" name="Slide Image Placeholder 1"/>
+          <p:cNvSpPr>
+            <a:spLocks noGrp="1"/>
+          </p:cNvSpPr>
+          <p:nvPr>
+            <p:ph type="sldImg" idx="2"/>
+          </p:nvPr>
+        </p:nvSpPr>
+        <p:spPr/>
+      </p:sp>
+      <p:sp>
+        <p:nvSpPr>
+          <p:cNvPr id="3" name="Notes Placeholder 2"/>
+          <p:cNvSpPr>
+            <a:spLocks noGrp="1"/>
+          </p:cNvSpPr>
+          <p:nvPr>
+            <p:ph type="body" idx="3" sz="quarter"/>
+          </p:nvPr>
+        </p:nvSpPr>
+        <p:spPr/>
+        <p:txBody>
+          <a:bodyPr/>
+          <a:lstStyle/>
+          <a:p>
+            <a:r>
+              <a:t>Fragen 1 und 3 gemeinsam besprechen. Ausblick VA07 – Schnittstelle Berater–Assistenz aktiv gestalten.</a:t>
             </a:r>
           </a:p>
         </p:txBody>
@@ -4304,6 +4657,2566 @@
 </p:sld>
 </file>
 
+<file path=ppt/slides/slide10.xml><?xml version="1.0" encoding="utf-8"?>
+<p:sld xmlns:a="http://schemas.openxmlformats.org/drawingml/2006/main" xmlns:p="http://schemas.openxmlformats.org/presentationml/2006/main" xmlns:r="http://schemas.openxmlformats.org/officeDocument/2006/relationships">
+  <p:cSld>
+    <p:spTree>
+      <p:nvGrpSpPr>
+        <p:cNvPr id="1" name=""/>
+        <p:cNvGrpSpPr/>
+        <p:nvPr/>
+      </p:nvGrpSpPr>
+      <p:grpSpPr/>
+      <p:sp>
+        <p:nvSpPr>
+          <p:cNvPr id="2" name="Rectangle 1"/>
+          <p:cNvSpPr/>
+          <p:nvPr/>
+        </p:nvSpPr>
+        <p:spPr>
+          <a:xfrm>
+            <a:off x="0" y="0"/>
+            <a:ext cx="12188952" cy="6858000"/>
+          </a:xfrm>
+          <a:prstGeom prst="rect">
+            <a:avLst/>
+          </a:prstGeom>
+          <a:solidFill>
+            <a:srgbClr val="EDEDF3"/>
+          </a:solidFill>
+          <a:ln>
+            <a:noFill/>
+          </a:ln>
+        </p:spPr>
+        <p:style>
+          <a:lnRef idx="1">
+            <a:schemeClr val="accent1"/>
+          </a:lnRef>
+          <a:fillRef idx="3">
+            <a:schemeClr val="accent1"/>
+          </a:fillRef>
+          <a:effectRef idx="2">
+            <a:schemeClr val="accent1"/>
+          </a:effectRef>
+          <a:fontRef idx="minor">
+            <a:schemeClr val="lt1"/>
+          </a:fontRef>
+        </p:style>
+        <p:txBody>
+          <a:bodyPr rtlCol="0" anchor="ctr"/>
+          <a:lstStyle/>
+          <a:p>
+            <a:pPr algn="ctr"/>
+          </a:p>
+        </p:txBody>
+      </p:sp>
+      <p:sp>
+        <p:nvSpPr>
+          <p:cNvPr id="3" name="Rectangle 2"/>
+          <p:cNvSpPr/>
+          <p:nvPr/>
+        </p:nvSpPr>
+        <p:spPr>
+          <a:xfrm>
+            <a:off x="0" y="0"/>
+            <a:ext cx="12188952" cy="50292"/>
+          </a:xfrm>
+          <a:prstGeom prst="rect">
+            <a:avLst/>
+          </a:prstGeom>
+          <a:solidFill>
+            <a:srgbClr val="1F2C56"/>
+          </a:solidFill>
+          <a:ln>
+            <a:noFill/>
+          </a:ln>
+        </p:spPr>
+        <p:style>
+          <a:lnRef idx="1">
+            <a:schemeClr val="accent1"/>
+          </a:lnRef>
+          <a:fillRef idx="3">
+            <a:schemeClr val="accent1"/>
+          </a:fillRef>
+          <a:effectRef idx="2">
+            <a:schemeClr val="accent1"/>
+          </a:effectRef>
+          <a:fontRef idx="minor">
+            <a:schemeClr val="lt1"/>
+          </a:fontRef>
+        </p:style>
+        <p:txBody>
+          <a:bodyPr rtlCol="0" anchor="ctr"/>
+          <a:lstStyle/>
+          <a:p>
+            <a:pPr algn="ctr"/>
+          </a:p>
+        </p:txBody>
+      </p:sp>
+      <p:sp>
+        <p:nvSpPr>
+          <p:cNvPr id="4" name="TextBox 3"/>
+          <p:cNvSpPr txBox="1"/>
+          <p:nvPr/>
+        </p:nvSpPr>
+        <p:spPr>
+          <a:xfrm>
+            <a:off x="685800" y="109728"/>
+            <a:ext cx="10817352" cy="228600"/>
+          </a:xfrm>
+          <a:prstGeom prst="rect">
+            <a:avLst/>
+          </a:prstGeom>
+          <a:noFill/>
+        </p:spPr>
+        <p:txBody>
+          <a:bodyPr wrap="none">
+            <a:spAutoFit/>
+          </a:bodyPr>
+          <a:lstStyle/>
+          <a:p>
+            <a:pPr algn="l"/>
+            <a:r>
+              <a:rPr sz="750">
+                <a:solidFill>
+                  <a:srgbClr val="78808C"/>
+                </a:solidFill>
+                <a:latin typeface="Consolas"/>
+              </a:rPr>
+              <a:t>VA06  ·  INHALT</a:t>
+            </a:r>
+          </a:p>
+        </p:txBody>
+      </p:sp>
+      <p:sp>
+        <p:nvSpPr>
+          <p:cNvPr id="5" name="Rectangle 4"/>
+          <p:cNvSpPr/>
+          <p:nvPr/>
+        </p:nvSpPr>
+        <p:spPr>
+          <a:xfrm>
+            <a:off x="0" y="1234440"/>
+            <a:ext cx="12188952" cy="12700"/>
+          </a:xfrm>
+          <a:prstGeom prst="rect">
+            <a:avLst/>
+          </a:prstGeom>
+          <a:solidFill>
+            <a:srgbClr val="D8DFE4"/>
+          </a:solidFill>
+          <a:ln>
+            <a:noFill/>
+          </a:ln>
+        </p:spPr>
+        <p:style>
+          <a:lnRef idx="1">
+            <a:schemeClr val="accent1"/>
+          </a:lnRef>
+          <a:fillRef idx="3">
+            <a:schemeClr val="accent1"/>
+          </a:fillRef>
+          <a:effectRef idx="2">
+            <a:schemeClr val="accent1"/>
+          </a:effectRef>
+          <a:fontRef idx="minor">
+            <a:schemeClr val="lt1"/>
+          </a:fontRef>
+        </p:style>
+        <p:txBody>
+          <a:bodyPr rtlCol="0" anchor="ctr"/>
+          <a:lstStyle/>
+          <a:p>
+            <a:pPr algn="ctr"/>
+          </a:p>
+        </p:txBody>
+      </p:sp>
+      <p:sp>
+        <p:nvSpPr>
+          <p:cNvPr id="6" name="Rectangle 5"/>
+          <p:cNvSpPr/>
+          <p:nvPr/>
+        </p:nvSpPr>
+        <p:spPr>
+          <a:xfrm>
+            <a:off x="685800" y="502920"/>
+            <a:ext cx="36576" cy="658368"/>
+          </a:xfrm>
+          <a:prstGeom prst="rect">
+            <a:avLst/>
+          </a:prstGeom>
+          <a:solidFill>
+            <a:srgbClr val="D9C089"/>
+          </a:solidFill>
+          <a:ln>
+            <a:noFill/>
+          </a:ln>
+        </p:spPr>
+        <p:style>
+          <a:lnRef idx="1">
+            <a:schemeClr val="accent1"/>
+          </a:lnRef>
+          <a:fillRef idx="3">
+            <a:schemeClr val="accent1"/>
+          </a:fillRef>
+          <a:effectRef idx="2">
+            <a:schemeClr val="accent1"/>
+          </a:effectRef>
+          <a:fontRef idx="minor">
+            <a:schemeClr val="lt1"/>
+          </a:fontRef>
+        </p:style>
+        <p:txBody>
+          <a:bodyPr rtlCol="0" anchor="ctr"/>
+          <a:lstStyle/>
+          <a:p>
+            <a:pPr algn="ctr"/>
+          </a:p>
+        </p:txBody>
+      </p:sp>
+      <p:sp>
+        <p:nvSpPr>
+          <p:cNvPr id="7" name="TextBox 6"/>
+          <p:cNvSpPr txBox="1"/>
+          <p:nvPr/>
+        </p:nvSpPr>
+        <p:spPr>
+          <a:xfrm>
+            <a:off x="813816" y="502920"/>
+            <a:ext cx="10634472" cy="685800"/>
+          </a:xfrm>
+          <a:prstGeom prst="rect">
+            <a:avLst/>
+          </a:prstGeom>
+          <a:noFill/>
+        </p:spPr>
+        <p:txBody>
+          <a:bodyPr wrap="square">
+            <a:spAutoFit/>
+          </a:bodyPr>
+          <a:lstStyle/>
+          <a:p>
+            <a:pPr algn="l"/>
+            <a:r>
+              <a:rPr sz="2400" b="1" i="0">
+                <a:solidFill>
+                  <a:srgbClr val="1F2C56"/>
+                </a:solidFill>
+                <a:latin typeface="Arial"/>
+              </a:rPr>
+              <a:t>Praxisfall: Jahresgespräch Handwerk Musterregion</a:t>
+            </a:r>
+          </a:p>
+        </p:txBody>
+      </p:sp>
+      <p:sp>
+        <p:nvSpPr>
+          <p:cNvPr id="8" name="TextBox 7"/>
+          <p:cNvSpPr txBox="1"/>
+          <p:nvPr/>
+        </p:nvSpPr>
+        <p:spPr>
+          <a:xfrm>
+            <a:off x="685800" y="1417320"/>
+            <a:ext cx="10817352" cy="4892040"/>
+          </a:xfrm>
+          <a:prstGeom prst="rect">
+            <a:avLst/>
+          </a:prstGeom>
+          <a:noFill/>
+        </p:spPr>
+        <p:txBody>
+          <a:bodyPr wrap="square" anchor="ctr">
+            <a:spAutoFit/>
+          </a:bodyPr>
+          <a:lstStyle/>
+          <a:p>
+            <a:pPr>
+              <a:spcBef>
+                <a:spcPts val="1000"/>
+              </a:spcBef>
+              <a:spcAft>
+                <a:spcPts val="200"/>
+              </a:spcAft>
+            </a:pPr>
+            <a:r>
+              <a:rPr sz="800" b="1">
+                <a:solidFill>
+                  <a:srgbClr val="78808C"/>
+                </a:solidFill>
+                <a:latin typeface="Consolas"/>
+              </a:rPr>
+              <a:t>AUS DER HISTORIE</a:t>
+            </a:r>
+          </a:p>
+          <a:p>
+            <a:pPr marL="190500" indent="-190500">
+              <a:spcBef>
+                <a:spcPts val="400"/>
+              </a:spcBef>
+              <a:spcAft>
+                <a:spcPts val="200"/>
+              </a:spcAft>
+            </a:pPr>
+            <a:r>
+              <a:rPr sz="1300">
+                <a:solidFill>
+                  <a:srgbClr val="3D5466"/>
+                </a:solidFill>
+                <a:latin typeface="Arial"/>
+              </a:rPr>
+              <a:t>▸  Betriebsmittellinie zu 95 % ausgelastet; Zinsbindung eines Darlehens läuft in 4 Monaten aus.</a:t>
+            </a:r>
+          </a:p>
+          <a:p>
+            <a:pPr marL="190500" indent="-190500">
+              <a:spcBef>
+                <a:spcPts val="400"/>
+              </a:spcBef>
+              <a:spcAft>
+                <a:spcPts val="200"/>
+              </a:spcAft>
+            </a:pPr>
+            <a:r>
+              <a:rPr sz="1300">
+                <a:solidFill>
+                  <a:srgbClr val="3D5466"/>
+                </a:solidFill>
+                <a:latin typeface="Arial"/>
+              </a:rPr>
+              <a:t>▸  Im letzten Gespräch wurde eine Investition „nächstes Jahr" angedeutet; eine BWA fehlt noch.</a:t>
+            </a:r>
+          </a:p>
+          <a:p>
+            <a:pPr>
+              <a:spcBef>
+                <a:spcPts val="1000"/>
+              </a:spcBef>
+              <a:spcAft>
+                <a:spcPts val="200"/>
+              </a:spcAft>
+            </a:pPr>
+            <a:r>
+              <a:rPr sz="800" b="1">
+                <a:solidFill>
+                  <a:srgbClr val="78808C"/>
+                </a:solidFill>
+                <a:latin typeface="Consolas"/>
+              </a:rPr>
+              <a:t>IHRE AUFGABE</a:t>
+            </a:r>
+          </a:p>
+          <a:p>
+            <a:pPr marL="190500" indent="-190500">
+              <a:spcBef>
+                <a:spcPts val="400"/>
+              </a:spcBef>
+              <a:spcAft>
+                <a:spcPts val="200"/>
+              </a:spcAft>
+            </a:pPr>
+            <a:r>
+              <a:rPr sz="1300">
+                <a:solidFill>
+                  <a:srgbClr val="3D5466"/>
+                </a:solidFill>
+                <a:latin typeface="Arial"/>
+              </a:rPr>
+              <a:t>▸  Bereiten Sie die Terminmappe vor – die Unterlagen sind bewusst unstrukturiert, das ist Alltag.</a:t>
+            </a:r>
+          </a:p>
+        </p:txBody>
+      </p:sp>
+      <p:sp>
+        <p:nvSpPr>
+          <p:cNvPr id="9" name="Rectangle 8"/>
+          <p:cNvSpPr/>
+          <p:nvPr/>
+        </p:nvSpPr>
+        <p:spPr>
+          <a:xfrm>
+            <a:off x="0" y="6510528"/>
+            <a:ext cx="12188952" cy="347472"/>
+          </a:xfrm>
+          <a:prstGeom prst="rect">
+            <a:avLst/>
+          </a:prstGeom>
+          <a:solidFill>
+            <a:srgbClr val="0A1937"/>
+          </a:solidFill>
+          <a:ln>
+            <a:noFill/>
+          </a:ln>
+        </p:spPr>
+        <p:style>
+          <a:lnRef idx="1">
+            <a:schemeClr val="accent1"/>
+          </a:lnRef>
+          <a:fillRef idx="3">
+            <a:schemeClr val="accent1"/>
+          </a:fillRef>
+          <a:effectRef idx="2">
+            <a:schemeClr val="accent1"/>
+          </a:effectRef>
+          <a:fontRef idx="minor">
+            <a:schemeClr val="lt1"/>
+          </a:fontRef>
+        </p:style>
+        <p:txBody>
+          <a:bodyPr rtlCol="0" anchor="ctr"/>
+          <a:lstStyle/>
+          <a:p>
+            <a:pPr algn="ctr"/>
+          </a:p>
+        </p:txBody>
+      </p:sp>
+      <p:sp>
+        <p:nvSpPr>
+          <p:cNvPr id="10" name="TextBox 9"/>
+          <p:cNvSpPr txBox="1"/>
+          <p:nvPr/>
+        </p:nvSpPr>
+        <p:spPr>
+          <a:xfrm>
+            <a:off x="685800" y="6583680"/>
+            <a:ext cx="6490411" cy="256032"/>
+          </a:xfrm>
+          <a:prstGeom prst="rect">
+            <a:avLst/>
+          </a:prstGeom>
+          <a:noFill/>
+        </p:spPr>
+        <p:txBody>
+          <a:bodyPr wrap="none">
+            <a:spAutoFit/>
+          </a:bodyPr>
+          <a:lstStyle/>
+          <a:p>
+            <a:pPr algn="l"/>
+            <a:r>
+              <a:rPr sz="700">
+                <a:solidFill>
+                  <a:srgbClr val="A0B4D2"/>
+                </a:solidFill>
+                <a:latin typeface="Consolas"/>
+              </a:rPr>
+              <a:t>FKB Campus  ·  VA06</a:t>
+            </a:r>
+          </a:p>
+        </p:txBody>
+      </p:sp>
+    </p:spTree>
+  </p:cSld>
+  <p:clrMapOvr>
+    <a:masterClrMapping/>
+  </p:clrMapOvr>
+</p:sld>
+</file>
+
+<file path=ppt/slides/slide11.xml><?xml version="1.0" encoding="utf-8"?>
+<p:sld xmlns:a="http://schemas.openxmlformats.org/drawingml/2006/main" xmlns:p="http://schemas.openxmlformats.org/presentationml/2006/main" xmlns:r="http://schemas.openxmlformats.org/officeDocument/2006/relationships">
+  <p:cSld>
+    <p:spTree>
+      <p:nvGrpSpPr>
+        <p:cNvPr id="1" name=""/>
+        <p:cNvGrpSpPr/>
+        <p:nvPr/>
+      </p:nvGrpSpPr>
+      <p:grpSpPr/>
+      <p:sp>
+        <p:nvSpPr>
+          <p:cNvPr id="2" name="Rectangle 1"/>
+          <p:cNvSpPr/>
+          <p:nvPr/>
+        </p:nvSpPr>
+        <p:spPr>
+          <a:xfrm>
+            <a:off x="0" y="0"/>
+            <a:ext cx="12188952" cy="6858000"/>
+          </a:xfrm>
+          <a:prstGeom prst="rect">
+            <a:avLst/>
+          </a:prstGeom>
+          <a:solidFill>
+            <a:srgbClr val="EDEDF3"/>
+          </a:solidFill>
+          <a:ln>
+            <a:noFill/>
+          </a:ln>
+        </p:spPr>
+        <p:style>
+          <a:lnRef idx="1">
+            <a:schemeClr val="accent1"/>
+          </a:lnRef>
+          <a:fillRef idx="3">
+            <a:schemeClr val="accent1"/>
+          </a:fillRef>
+          <a:effectRef idx="2">
+            <a:schemeClr val="accent1"/>
+          </a:effectRef>
+          <a:fontRef idx="minor">
+            <a:schemeClr val="lt1"/>
+          </a:fontRef>
+        </p:style>
+        <p:txBody>
+          <a:bodyPr rtlCol="0" anchor="ctr"/>
+          <a:lstStyle/>
+          <a:p>
+            <a:pPr algn="ctr"/>
+          </a:p>
+        </p:txBody>
+      </p:sp>
+      <p:sp>
+        <p:nvSpPr>
+          <p:cNvPr id="3" name="Rectangle 2"/>
+          <p:cNvSpPr/>
+          <p:nvPr/>
+        </p:nvSpPr>
+        <p:spPr>
+          <a:xfrm>
+            <a:off x="0" y="0"/>
+            <a:ext cx="12188952" cy="50292"/>
+          </a:xfrm>
+          <a:prstGeom prst="rect">
+            <a:avLst/>
+          </a:prstGeom>
+          <a:solidFill>
+            <a:srgbClr val="1F2C56"/>
+          </a:solidFill>
+          <a:ln>
+            <a:noFill/>
+          </a:ln>
+        </p:spPr>
+        <p:style>
+          <a:lnRef idx="1">
+            <a:schemeClr val="accent1"/>
+          </a:lnRef>
+          <a:fillRef idx="3">
+            <a:schemeClr val="accent1"/>
+          </a:fillRef>
+          <a:effectRef idx="2">
+            <a:schemeClr val="accent1"/>
+          </a:effectRef>
+          <a:fontRef idx="minor">
+            <a:schemeClr val="lt1"/>
+          </a:fontRef>
+        </p:style>
+        <p:txBody>
+          <a:bodyPr rtlCol="0" anchor="ctr"/>
+          <a:lstStyle/>
+          <a:p>
+            <a:pPr algn="ctr"/>
+          </a:p>
+        </p:txBody>
+      </p:sp>
+      <p:sp>
+        <p:nvSpPr>
+          <p:cNvPr id="4" name="TextBox 3"/>
+          <p:cNvSpPr txBox="1"/>
+          <p:nvPr/>
+        </p:nvSpPr>
+        <p:spPr>
+          <a:xfrm>
+            <a:off x="685800" y="109728"/>
+            <a:ext cx="10817352" cy="228600"/>
+          </a:xfrm>
+          <a:prstGeom prst="rect">
+            <a:avLst/>
+          </a:prstGeom>
+          <a:noFill/>
+        </p:spPr>
+        <p:txBody>
+          <a:bodyPr wrap="none">
+            <a:spAutoFit/>
+          </a:bodyPr>
+          <a:lstStyle/>
+          <a:p>
+            <a:pPr algn="l"/>
+            <a:r>
+              <a:rPr sz="750">
+                <a:solidFill>
+                  <a:srgbClr val="78808C"/>
+                </a:solidFill>
+                <a:latin typeface="Consolas"/>
+              </a:rPr>
+              <a:t>VA06  ·  INHALT</a:t>
+            </a:r>
+          </a:p>
+        </p:txBody>
+      </p:sp>
+      <p:sp>
+        <p:nvSpPr>
+          <p:cNvPr id="5" name="Rectangle 4"/>
+          <p:cNvSpPr/>
+          <p:nvPr/>
+        </p:nvSpPr>
+        <p:spPr>
+          <a:xfrm>
+            <a:off x="0" y="1234440"/>
+            <a:ext cx="12188952" cy="12700"/>
+          </a:xfrm>
+          <a:prstGeom prst="rect">
+            <a:avLst/>
+          </a:prstGeom>
+          <a:solidFill>
+            <a:srgbClr val="D8DFE4"/>
+          </a:solidFill>
+          <a:ln>
+            <a:noFill/>
+          </a:ln>
+        </p:spPr>
+        <p:style>
+          <a:lnRef idx="1">
+            <a:schemeClr val="accent1"/>
+          </a:lnRef>
+          <a:fillRef idx="3">
+            <a:schemeClr val="accent1"/>
+          </a:fillRef>
+          <a:effectRef idx="2">
+            <a:schemeClr val="accent1"/>
+          </a:effectRef>
+          <a:fontRef idx="minor">
+            <a:schemeClr val="lt1"/>
+          </a:fontRef>
+        </p:style>
+        <p:txBody>
+          <a:bodyPr rtlCol="0" anchor="ctr"/>
+          <a:lstStyle/>
+          <a:p>
+            <a:pPr algn="ctr"/>
+          </a:p>
+        </p:txBody>
+      </p:sp>
+      <p:sp>
+        <p:nvSpPr>
+          <p:cNvPr id="6" name="Rectangle 5"/>
+          <p:cNvSpPr/>
+          <p:nvPr/>
+        </p:nvSpPr>
+        <p:spPr>
+          <a:xfrm>
+            <a:off x="685800" y="502920"/>
+            <a:ext cx="36576" cy="658368"/>
+          </a:xfrm>
+          <a:prstGeom prst="rect">
+            <a:avLst/>
+          </a:prstGeom>
+          <a:solidFill>
+            <a:srgbClr val="D9C089"/>
+          </a:solidFill>
+          <a:ln>
+            <a:noFill/>
+          </a:ln>
+        </p:spPr>
+        <p:style>
+          <a:lnRef idx="1">
+            <a:schemeClr val="accent1"/>
+          </a:lnRef>
+          <a:fillRef idx="3">
+            <a:schemeClr val="accent1"/>
+          </a:fillRef>
+          <a:effectRef idx="2">
+            <a:schemeClr val="accent1"/>
+          </a:effectRef>
+          <a:fontRef idx="minor">
+            <a:schemeClr val="lt1"/>
+          </a:fontRef>
+        </p:style>
+        <p:txBody>
+          <a:bodyPr rtlCol="0" anchor="ctr"/>
+          <a:lstStyle/>
+          <a:p>
+            <a:pPr algn="ctr"/>
+          </a:p>
+        </p:txBody>
+      </p:sp>
+      <p:sp>
+        <p:nvSpPr>
+          <p:cNvPr id="7" name="TextBox 6"/>
+          <p:cNvSpPr txBox="1"/>
+          <p:nvPr/>
+        </p:nvSpPr>
+        <p:spPr>
+          <a:xfrm>
+            <a:off x="813816" y="502920"/>
+            <a:ext cx="10634472" cy="685800"/>
+          </a:xfrm>
+          <a:prstGeom prst="rect">
+            <a:avLst/>
+          </a:prstGeom>
+          <a:noFill/>
+        </p:spPr>
+        <p:txBody>
+          <a:bodyPr wrap="square">
+            <a:spAutoFit/>
+          </a:bodyPr>
+          <a:lstStyle/>
+          <a:p>
+            <a:pPr algn="l"/>
+            <a:r>
+              <a:rPr sz="2400" b="1" i="0">
+                <a:solidFill>
+                  <a:srgbClr val="1F2C56"/>
+                </a:solidFill>
+                <a:latin typeface="Arial"/>
+              </a:rPr>
+              <a:t>Handlungsempfehlung: markieren statt merken</a:t>
+            </a:r>
+          </a:p>
+        </p:txBody>
+      </p:sp>
+      <p:sp>
+        <p:nvSpPr>
+          <p:cNvPr id="8" name="TextBox 7"/>
+          <p:cNvSpPr txBox="1"/>
+          <p:nvPr/>
+        </p:nvSpPr>
+        <p:spPr>
+          <a:xfrm>
+            <a:off x="685800" y="1417320"/>
+            <a:ext cx="10817352" cy="4892040"/>
+          </a:xfrm>
+          <a:prstGeom prst="rect">
+            <a:avLst/>
+          </a:prstGeom>
+          <a:noFill/>
+        </p:spPr>
+        <p:txBody>
+          <a:bodyPr wrap="square" anchor="ctr">
+            <a:spAutoFit/>
+          </a:bodyPr>
+          <a:lstStyle/>
+          <a:p>
+            <a:pPr marL="177800" indent="-177800">
+              <a:spcBef>
+                <a:spcPts val="600"/>
+              </a:spcBef>
+              <a:spcAft>
+                <a:spcPts val="200"/>
+              </a:spcAft>
+            </a:pPr>
+            <a:r>
+              <a:rPr sz="1200" i="1">
+                <a:solidFill>
+                  <a:srgbClr val="3D5466"/>
+                </a:solidFill>
+                <a:latin typeface="Arial"/>
+              </a:rPr>
+              <a:t>→  Wenn Sie eine Terminmappe erstellen — dann jeden Anlass als offenen Punkt markieren, damit der Berater ihn im Gespräch ansprechen kann.</a:t>
+            </a:r>
+          </a:p>
+          <a:p>
+            <a:pPr marL="177800" indent="-177800">
+              <a:spcBef>
+                <a:spcPts val="600"/>
+              </a:spcBef>
+              <a:spcAft>
+                <a:spcPts val="200"/>
+              </a:spcAft>
+            </a:pPr>
+            <a:r>
+              <a:rPr sz="1200" i="1">
+                <a:solidFill>
+                  <a:srgbClr val="3D5466"/>
+                </a:solidFill>
+                <a:latin typeface="Arial"/>
+              </a:rPr>
+              <a:t>→  Wenn der Kunde etwas nur andeutet — dann genau das festhalten; die Andeutung geht sonst im nächsten Termin verloren.</a:t>
+            </a:r>
+          </a:p>
+          <a:p>
+            <a:pPr marL="177800" indent="-177800">
+              <a:spcBef>
+                <a:spcPts val="600"/>
+              </a:spcBef>
+              <a:spcAft>
+                <a:spcPts val="200"/>
+              </a:spcAft>
+            </a:pPr>
+            <a:r>
+              <a:rPr sz="1200" i="1">
+                <a:solidFill>
+                  <a:srgbClr val="3D5466"/>
+                </a:solidFill>
+                <a:latin typeface="Arial"/>
+              </a:rPr>
+              <a:t>→  Wenn nach dem Termin Ergebnisse anfallen — dann sofort Wiedervorlagen mit realistischer Frist setzen, nichts mündlich merken.</a:t>
+            </a:r>
+          </a:p>
+        </p:txBody>
+      </p:sp>
+      <p:sp>
+        <p:nvSpPr>
+          <p:cNvPr id="9" name="Rectangle 8"/>
+          <p:cNvSpPr/>
+          <p:nvPr/>
+        </p:nvSpPr>
+        <p:spPr>
+          <a:xfrm>
+            <a:off x="0" y="6510528"/>
+            <a:ext cx="12188952" cy="347472"/>
+          </a:xfrm>
+          <a:prstGeom prst="rect">
+            <a:avLst/>
+          </a:prstGeom>
+          <a:solidFill>
+            <a:srgbClr val="0A1937"/>
+          </a:solidFill>
+          <a:ln>
+            <a:noFill/>
+          </a:ln>
+        </p:spPr>
+        <p:style>
+          <a:lnRef idx="1">
+            <a:schemeClr val="accent1"/>
+          </a:lnRef>
+          <a:fillRef idx="3">
+            <a:schemeClr val="accent1"/>
+          </a:fillRef>
+          <a:effectRef idx="2">
+            <a:schemeClr val="accent1"/>
+          </a:effectRef>
+          <a:fontRef idx="minor">
+            <a:schemeClr val="lt1"/>
+          </a:fontRef>
+        </p:style>
+        <p:txBody>
+          <a:bodyPr rtlCol="0" anchor="ctr"/>
+          <a:lstStyle/>
+          <a:p>
+            <a:pPr algn="ctr"/>
+          </a:p>
+        </p:txBody>
+      </p:sp>
+      <p:sp>
+        <p:nvSpPr>
+          <p:cNvPr id="10" name="TextBox 9"/>
+          <p:cNvSpPr txBox="1"/>
+          <p:nvPr/>
+        </p:nvSpPr>
+        <p:spPr>
+          <a:xfrm>
+            <a:off x="685800" y="6583680"/>
+            <a:ext cx="6490411" cy="256032"/>
+          </a:xfrm>
+          <a:prstGeom prst="rect">
+            <a:avLst/>
+          </a:prstGeom>
+          <a:noFill/>
+        </p:spPr>
+        <p:txBody>
+          <a:bodyPr wrap="none">
+            <a:spAutoFit/>
+          </a:bodyPr>
+          <a:lstStyle/>
+          <a:p>
+            <a:pPr algn="l"/>
+            <a:r>
+              <a:rPr sz="700">
+                <a:solidFill>
+                  <a:srgbClr val="A0B4D2"/>
+                </a:solidFill>
+                <a:latin typeface="Consolas"/>
+              </a:rPr>
+              <a:t>FKB Campus  ·  VA06</a:t>
+            </a:r>
+          </a:p>
+        </p:txBody>
+      </p:sp>
+    </p:spTree>
+  </p:cSld>
+  <p:clrMapOvr>
+    <a:masterClrMapping/>
+  </p:clrMapOvr>
+</p:sld>
+</file>
+
+<file path=ppt/slides/slide12.xml><?xml version="1.0" encoding="utf-8"?>
+<p:sld xmlns:a="http://schemas.openxmlformats.org/drawingml/2006/main" xmlns:p="http://schemas.openxmlformats.org/presentationml/2006/main" xmlns:r="http://schemas.openxmlformats.org/officeDocument/2006/relationships">
+  <p:cSld>
+    <p:spTree>
+      <p:nvGrpSpPr>
+        <p:cNvPr id="1" name=""/>
+        <p:cNvGrpSpPr/>
+        <p:nvPr/>
+      </p:nvGrpSpPr>
+      <p:grpSpPr/>
+      <p:sp>
+        <p:nvSpPr>
+          <p:cNvPr id="2" name="Rectangle 1"/>
+          <p:cNvSpPr/>
+          <p:nvPr/>
+        </p:nvSpPr>
+        <p:spPr>
+          <a:xfrm>
+            <a:off x="0" y="0"/>
+            <a:ext cx="12188952" cy="6858000"/>
+          </a:xfrm>
+          <a:prstGeom prst="rect">
+            <a:avLst/>
+          </a:prstGeom>
+          <a:solidFill>
+            <a:srgbClr val="FFFFFF"/>
+          </a:solidFill>
+          <a:ln>
+            <a:noFill/>
+          </a:ln>
+        </p:spPr>
+        <p:style>
+          <a:lnRef idx="1">
+            <a:schemeClr val="accent1"/>
+          </a:lnRef>
+          <a:fillRef idx="3">
+            <a:schemeClr val="accent1"/>
+          </a:fillRef>
+          <a:effectRef idx="2">
+            <a:schemeClr val="accent1"/>
+          </a:effectRef>
+          <a:fontRef idx="minor">
+            <a:schemeClr val="lt1"/>
+          </a:fontRef>
+        </p:style>
+        <p:txBody>
+          <a:bodyPr rtlCol="0" anchor="ctr"/>
+          <a:lstStyle/>
+          <a:p>
+            <a:pPr algn="ctr"/>
+          </a:p>
+        </p:txBody>
+      </p:sp>
+      <p:sp>
+        <p:nvSpPr>
+          <p:cNvPr id="3" name="Rectangle 2"/>
+          <p:cNvSpPr/>
+          <p:nvPr/>
+        </p:nvSpPr>
+        <p:spPr>
+          <a:xfrm>
+            <a:off x="0" y="0"/>
+            <a:ext cx="12188952" cy="50292"/>
+          </a:xfrm>
+          <a:prstGeom prst="rect">
+            <a:avLst/>
+          </a:prstGeom>
+          <a:solidFill>
+            <a:srgbClr val="1F2C56"/>
+          </a:solidFill>
+          <a:ln>
+            <a:noFill/>
+          </a:ln>
+        </p:spPr>
+        <p:style>
+          <a:lnRef idx="1">
+            <a:schemeClr val="accent1"/>
+          </a:lnRef>
+          <a:fillRef idx="3">
+            <a:schemeClr val="accent1"/>
+          </a:fillRef>
+          <a:effectRef idx="2">
+            <a:schemeClr val="accent1"/>
+          </a:effectRef>
+          <a:fontRef idx="minor">
+            <a:schemeClr val="lt1"/>
+          </a:fontRef>
+        </p:style>
+        <p:txBody>
+          <a:bodyPr rtlCol="0" anchor="ctr"/>
+          <a:lstStyle/>
+          <a:p>
+            <a:pPr algn="ctr"/>
+          </a:p>
+        </p:txBody>
+      </p:sp>
+      <p:sp>
+        <p:nvSpPr>
+          <p:cNvPr id="4" name="TextBox 3"/>
+          <p:cNvSpPr txBox="1"/>
+          <p:nvPr/>
+        </p:nvSpPr>
+        <p:spPr>
+          <a:xfrm>
+            <a:off x="685800" y="109728"/>
+            <a:ext cx="10817352" cy="228600"/>
+          </a:xfrm>
+          <a:prstGeom prst="rect">
+            <a:avLst/>
+          </a:prstGeom>
+          <a:noFill/>
+        </p:spPr>
+        <p:txBody>
+          <a:bodyPr wrap="none">
+            <a:spAutoFit/>
+          </a:bodyPr>
+          <a:lstStyle/>
+          <a:p>
+            <a:pPr algn="l"/>
+            <a:r>
+              <a:rPr sz="750">
+                <a:solidFill>
+                  <a:srgbClr val="78808C"/>
+                </a:solidFill>
+                <a:latin typeface="Consolas"/>
+              </a:rPr>
+              <a:t>VA06  ·  SCHAUBILD</a:t>
+            </a:r>
+          </a:p>
+        </p:txBody>
+      </p:sp>
+      <p:sp>
+        <p:nvSpPr>
+          <p:cNvPr id="5" name="TextBox 4"/>
+          <p:cNvSpPr txBox="1"/>
+          <p:nvPr/>
+        </p:nvSpPr>
+        <p:spPr>
+          <a:xfrm>
+            <a:off x="685800" y="502920"/>
+            <a:ext cx="10817352" cy="594360"/>
+          </a:xfrm>
+          <a:prstGeom prst="rect">
+            <a:avLst/>
+          </a:prstGeom>
+          <a:noFill/>
+        </p:spPr>
+        <p:txBody>
+          <a:bodyPr wrap="square">
+            <a:spAutoFit/>
+          </a:bodyPr>
+          <a:lstStyle/>
+          <a:p>
+            <a:pPr algn="l"/>
+            <a:r>
+              <a:rPr sz="2000" b="1" i="0">
+                <a:solidFill>
+                  <a:srgbClr val="1F2C56"/>
+                </a:solidFill>
+                <a:latin typeface="Arial"/>
+              </a:rPr>
+              <a:t>Nachbereitung als Kreislauf (Kolb)</a:t>
+            </a:r>
+          </a:p>
+        </p:txBody>
+      </p:sp>
+      <p:sp>
+        <p:nvSpPr>
+          <p:cNvPr id="6" name="Rectangle 5"/>
+          <p:cNvSpPr/>
+          <p:nvPr/>
+        </p:nvSpPr>
+        <p:spPr>
+          <a:xfrm>
+            <a:off x="685800" y="1143000"/>
+            <a:ext cx="10817352" cy="25400"/>
+          </a:xfrm>
+          <a:prstGeom prst="rect">
+            <a:avLst/>
+          </a:prstGeom>
+          <a:solidFill>
+            <a:srgbClr val="D9C089"/>
+          </a:solidFill>
+          <a:ln>
+            <a:noFill/>
+          </a:ln>
+        </p:spPr>
+        <p:style>
+          <a:lnRef idx="1">
+            <a:schemeClr val="accent1"/>
+          </a:lnRef>
+          <a:fillRef idx="3">
+            <a:schemeClr val="accent1"/>
+          </a:fillRef>
+          <a:effectRef idx="2">
+            <a:schemeClr val="accent1"/>
+          </a:effectRef>
+          <a:fontRef idx="minor">
+            <a:schemeClr val="lt1"/>
+          </a:fontRef>
+        </p:style>
+        <p:txBody>
+          <a:bodyPr rtlCol="0" anchor="ctr"/>
+          <a:lstStyle/>
+          <a:p>
+            <a:pPr algn="ctr"/>
+          </a:p>
+        </p:txBody>
+      </p:sp>
+      <p:pic>
+        <p:nvPicPr>
+          <p:cNvPr id="7" name="Picture 6" descr="image.png"/>
+          <p:cNvPicPr>
+            <a:picLocks noChangeAspect="1"/>
+          </p:cNvPicPr>
+          <p:nvPr/>
+        </p:nvPicPr>
+        <p:blipFill>
+          <a:blip r:embed="rId2"/>
+          <a:stretch>
+            <a:fillRect/>
+          </a:stretch>
+        </p:blipFill>
+        <p:spPr>
+          <a:xfrm>
+            <a:off x="2554863" y="1325880"/>
+            <a:ext cx="7079225" cy="4937760"/>
+          </a:xfrm>
+          <a:prstGeom prst="rect">
+            <a:avLst/>
+          </a:prstGeom>
+        </p:spPr>
+      </p:pic>
+      <p:sp>
+        <p:nvSpPr>
+          <p:cNvPr id="8" name="Rectangle 7"/>
+          <p:cNvSpPr/>
+          <p:nvPr/>
+        </p:nvSpPr>
+        <p:spPr>
+          <a:xfrm>
+            <a:off x="0" y="6510528"/>
+            <a:ext cx="12188952" cy="347472"/>
+          </a:xfrm>
+          <a:prstGeom prst="rect">
+            <a:avLst/>
+          </a:prstGeom>
+          <a:solidFill>
+            <a:srgbClr val="0A1937"/>
+          </a:solidFill>
+          <a:ln>
+            <a:noFill/>
+          </a:ln>
+        </p:spPr>
+        <p:style>
+          <a:lnRef idx="1">
+            <a:schemeClr val="accent1"/>
+          </a:lnRef>
+          <a:fillRef idx="3">
+            <a:schemeClr val="accent1"/>
+          </a:fillRef>
+          <a:effectRef idx="2">
+            <a:schemeClr val="accent1"/>
+          </a:effectRef>
+          <a:fontRef idx="minor">
+            <a:schemeClr val="lt1"/>
+          </a:fontRef>
+        </p:style>
+        <p:txBody>
+          <a:bodyPr rtlCol="0" anchor="ctr"/>
+          <a:lstStyle/>
+          <a:p>
+            <a:pPr algn="ctr"/>
+          </a:p>
+        </p:txBody>
+      </p:sp>
+      <p:sp>
+        <p:nvSpPr>
+          <p:cNvPr id="9" name="TextBox 8"/>
+          <p:cNvSpPr txBox="1"/>
+          <p:nvPr/>
+        </p:nvSpPr>
+        <p:spPr>
+          <a:xfrm>
+            <a:off x="685800" y="6583680"/>
+            <a:ext cx="6490411" cy="256032"/>
+          </a:xfrm>
+          <a:prstGeom prst="rect">
+            <a:avLst/>
+          </a:prstGeom>
+          <a:noFill/>
+        </p:spPr>
+        <p:txBody>
+          <a:bodyPr wrap="none">
+            <a:spAutoFit/>
+          </a:bodyPr>
+          <a:lstStyle/>
+          <a:p>
+            <a:pPr algn="l"/>
+            <a:r>
+              <a:rPr sz="700">
+                <a:solidFill>
+                  <a:srgbClr val="A0B4D2"/>
+                </a:solidFill>
+                <a:latin typeface="Consolas"/>
+              </a:rPr>
+              <a:t>FKB Campus  ·  VA06</a:t>
+            </a:r>
+          </a:p>
+        </p:txBody>
+      </p:sp>
+      <p:sp>
+        <p:nvSpPr>
+          <p:cNvPr id="10" name="TextBox 9"/>
+          <p:cNvSpPr txBox="1"/>
+          <p:nvPr/>
+        </p:nvSpPr>
+        <p:spPr>
+          <a:xfrm>
+            <a:off x="7176211" y="6583680"/>
+            <a:ext cx="4326940" cy="256032"/>
+          </a:xfrm>
+          <a:prstGeom prst="rect">
+            <a:avLst/>
+          </a:prstGeom>
+          <a:noFill/>
+        </p:spPr>
+        <p:txBody>
+          <a:bodyPr wrap="none">
+            <a:spAutoFit/>
+          </a:bodyPr>
+          <a:lstStyle/>
+          <a:p>
+            <a:pPr algn="r"/>
+            <a:r>
+              <a:rPr sz="700">
+                <a:solidFill>
+                  <a:srgbClr val="A0B4D2"/>
+                </a:solidFill>
+                <a:latin typeface="Consolas"/>
+              </a:rPr>
+              <a:t>Schaubild</a:t>
+            </a:r>
+          </a:p>
+        </p:txBody>
+      </p:sp>
+    </p:spTree>
+  </p:cSld>
+  <p:clrMapOvr>
+    <a:masterClrMapping/>
+  </p:clrMapOvr>
+</p:sld>
+</file>
+
+<file path=ppt/slides/slide13.xml><?xml version="1.0" encoding="utf-8"?>
+<p:sld xmlns:a="http://schemas.openxmlformats.org/drawingml/2006/main" xmlns:p="http://schemas.openxmlformats.org/presentationml/2006/main" xmlns:r="http://schemas.openxmlformats.org/officeDocument/2006/relationships">
+  <p:cSld>
+    <p:spTree>
+      <p:nvGrpSpPr>
+        <p:cNvPr id="1" name=""/>
+        <p:cNvGrpSpPr/>
+        <p:nvPr/>
+      </p:nvGrpSpPr>
+      <p:grpSpPr/>
+      <p:sp>
+        <p:nvSpPr>
+          <p:cNvPr id="2" name="Rectangle 1"/>
+          <p:cNvSpPr/>
+          <p:nvPr/>
+        </p:nvSpPr>
+        <p:spPr>
+          <a:xfrm>
+            <a:off x="0" y="0"/>
+            <a:ext cx="12188952" cy="6858000"/>
+          </a:xfrm>
+          <a:prstGeom prst="rect">
+            <a:avLst/>
+          </a:prstGeom>
+          <a:solidFill>
+            <a:srgbClr val="EDEDF3"/>
+          </a:solidFill>
+          <a:ln>
+            <a:noFill/>
+          </a:ln>
+        </p:spPr>
+        <p:style>
+          <a:lnRef idx="1">
+            <a:schemeClr val="accent1"/>
+          </a:lnRef>
+          <a:fillRef idx="3">
+            <a:schemeClr val="accent1"/>
+          </a:fillRef>
+          <a:effectRef idx="2">
+            <a:schemeClr val="accent1"/>
+          </a:effectRef>
+          <a:fontRef idx="minor">
+            <a:schemeClr val="lt1"/>
+          </a:fontRef>
+        </p:style>
+        <p:txBody>
+          <a:bodyPr rtlCol="0" anchor="ctr"/>
+          <a:lstStyle/>
+          <a:p>
+            <a:pPr algn="ctr"/>
+          </a:p>
+        </p:txBody>
+      </p:sp>
+      <p:sp>
+        <p:nvSpPr>
+          <p:cNvPr id="3" name="Rectangle 2"/>
+          <p:cNvSpPr/>
+          <p:nvPr/>
+        </p:nvSpPr>
+        <p:spPr>
+          <a:xfrm>
+            <a:off x="0" y="0"/>
+            <a:ext cx="12188952" cy="50292"/>
+          </a:xfrm>
+          <a:prstGeom prst="rect">
+            <a:avLst/>
+          </a:prstGeom>
+          <a:solidFill>
+            <a:srgbClr val="1F2C56"/>
+          </a:solidFill>
+          <a:ln>
+            <a:noFill/>
+          </a:ln>
+        </p:spPr>
+        <p:style>
+          <a:lnRef idx="1">
+            <a:schemeClr val="accent1"/>
+          </a:lnRef>
+          <a:fillRef idx="3">
+            <a:schemeClr val="accent1"/>
+          </a:fillRef>
+          <a:effectRef idx="2">
+            <a:schemeClr val="accent1"/>
+          </a:effectRef>
+          <a:fontRef idx="minor">
+            <a:schemeClr val="lt1"/>
+          </a:fontRef>
+        </p:style>
+        <p:txBody>
+          <a:bodyPr rtlCol="0" anchor="ctr"/>
+          <a:lstStyle/>
+          <a:p>
+            <a:pPr algn="ctr"/>
+          </a:p>
+        </p:txBody>
+      </p:sp>
+      <p:sp>
+        <p:nvSpPr>
+          <p:cNvPr id="4" name="TextBox 3"/>
+          <p:cNvSpPr txBox="1"/>
+          <p:nvPr/>
+        </p:nvSpPr>
+        <p:spPr>
+          <a:xfrm>
+            <a:off x="685800" y="109728"/>
+            <a:ext cx="10817352" cy="228600"/>
+          </a:xfrm>
+          <a:prstGeom prst="rect">
+            <a:avLst/>
+          </a:prstGeom>
+          <a:noFill/>
+        </p:spPr>
+        <p:txBody>
+          <a:bodyPr wrap="none">
+            <a:spAutoFit/>
+          </a:bodyPr>
+          <a:lstStyle/>
+          <a:p>
+            <a:pPr algn="l"/>
+            <a:r>
+              <a:rPr sz="750">
+                <a:solidFill>
+                  <a:srgbClr val="78808C"/>
+                </a:solidFill>
+                <a:latin typeface="Consolas"/>
+              </a:rPr>
+              <a:t>VA06  ·  ARBEITSBLATT</a:t>
+            </a:r>
+          </a:p>
+        </p:txBody>
+      </p:sp>
+      <p:sp>
+        <p:nvSpPr>
+          <p:cNvPr id="5" name="Rectangle 4"/>
+          <p:cNvSpPr/>
+          <p:nvPr/>
+        </p:nvSpPr>
+        <p:spPr>
+          <a:xfrm>
+            <a:off x="0" y="1234440"/>
+            <a:ext cx="12188952" cy="12700"/>
+          </a:xfrm>
+          <a:prstGeom prst="rect">
+            <a:avLst/>
+          </a:prstGeom>
+          <a:solidFill>
+            <a:srgbClr val="D8DFE4"/>
+          </a:solidFill>
+          <a:ln>
+            <a:noFill/>
+          </a:ln>
+        </p:spPr>
+        <p:style>
+          <a:lnRef idx="1">
+            <a:schemeClr val="accent1"/>
+          </a:lnRef>
+          <a:fillRef idx="3">
+            <a:schemeClr val="accent1"/>
+          </a:fillRef>
+          <a:effectRef idx="2">
+            <a:schemeClr val="accent1"/>
+          </a:effectRef>
+          <a:fontRef idx="minor">
+            <a:schemeClr val="lt1"/>
+          </a:fontRef>
+        </p:style>
+        <p:txBody>
+          <a:bodyPr rtlCol="0" anchor="ctr"/>
+          <a:lstStyle/>
+          <a:p>
+            <a:pPr algn="ctr"/>
+          </a:p>
+        </p:txBody>
+      </p:sp>
+      <p:sp>
+        <p:nvSpPr>
+          <p:cNvPr id="6" name="Rectangle 5"/>
+          <p:cNvSpPr/>
+          <p:nvPr/>
+        </p:nvSpPr>
+        <p:spPr>
+          <a:xfrm>
+            <a:off x="685800" y="502920"/>
+            <a:ext cx="36576" cy="658368"/>
+          </a:xfrm>
+          <a:prstGeom prst="rect">
+            <a:avLst/>
+          </a:prstGeom>
+          <a:solidFill>
+            <a:srgbClr val="D9C089"/>
+          </a:solidFill>
+          <a:ln>
+            <a:noFill/>
+          </a:ln>
+        </p:spPr>
+        <p:style>
+          <a:lnRef idx="1">
+            <a:schemeClr val="accent1"/>
+          </a:lnRef>
+          <a:fillRef idx="3">
+            <a:schemeClr val="accent1"/>
+          </a:fillRef>
+          <a:effectRef idx="2">
+            <a:schemeClr val="accent1"/>
+          </a:effectRef>
+          <a:fontRef idx="minor">
+            <a:schemeClr val="lt1"/>
+          </a:fontRef>
+        </p:style>
+        <p:txBody>
+          <a:bodyPr rtlCol="0" anchor="ctr"/>
+          <a:lstStyle/>
+          <a:p>
+            <a:pPr algn="ctr"/>
+          </a:p>
+        </p:txBody>
+      </p:sp>
+      <p:sp>
+        <p:nvSpPr>
+          <p:cNvPr id="7" name="TextBox 6"/>
+          <p:cNvSpPr txBox="1"/>
+          <p:nvPr/>
+        </p:nvSpPr>
+        <p:spPr>
+          <a:xfrm>
+            <a:off x="813816" y="502920"/>
+            <a:ext cx="10634472" cy="685800"/>
+          </a:xfrm>
+          <a:prstGeom prst="rect">
+            <a:avLst/>
+          </a:prstGeom>
+          <a:noFill/>
+        </p:spPr>
+        <p:txBody>
+          <a:bodyPr wrap="square">
+            <a:spAutoFit/>
+          </a:bodyPr>
+          <a:lstStyle/>
+          <a:p>
+            <a:pPr algn="l"/>
+            <a:r>
+              <a:rPr sz="2400" b="1" i="0">
+                <a:solidFill>
+                  <a:srgbClr val="1F2C56"/>
+                </a:solidFill>
+                <a:latin typeface="Arial"/>
+              </a:rPr>
+              <a:t>Praxisfall bearbeiten: Mappe und Nachbereitung</a:t>
+            </a:r>
+          </a:p>
+        </p:txBody>
+      </p:sp>
+      <p:sp>
+        <p:nvSpPr>
+          <p:cNvPr id="8" name="TextBox 7"/>
+          <p:cNvSpPr txBox="1"/>
+          <p:nvPr/>
+        </p:nvSpPr>
+        <p:spPr>
+          <a:xfrm>
+            <a:off x="685800" y="1554480"/>
+            <a:ext cx="10817352" cy="3840480"/>
+          </a:xfrm>
+          <a:prstGeom prst="rect">
+            <a:avLst/>
+          </a:prstGeom>
+          <a:noFill/>
+        </p:spPr>
+        <p:txBody>
+          <a:bodyPr wrap="square">
+            <a:spAutoFit/>
+          </a:bodyPr>
+          <a:lstStyle/>
+          <a:p>
+            <a:pPr marL="190500" indent="-190500">
+              <a:spcBef>
+                <a:spcPts val="400"/>
+              </a:spcBef>
+              <a:spcAft>
+                <a:spcPts val="200"/>
+              </a:spcAft>
+            </a:pPr>
+            <a:r>
+              <a:rPr sz="1400">
+                <a:solidFill>
+                  <a:srgbClr val="3D5466"/>
+                </a:solidFill>
+                <a:latin typeface="Arial"/>
+              </a:rPr>
+              <a:t>▸  Bestimmen Sie den Informationsbedarf für das Gespräch (AB-1).</a:t>
+            </a:r>
+          </a:p>
+          <a:p>
+            <a:pPr marL="190500" indent="-190500">
+              <a:spcBef>
+                <a:spcPts val="400"/>
+              </a:spcBef>
+              <a:spcAft>
+                <a:spcPts val="200"/>
+              </a:spcAft>
+            </a:pPr>
+            <a:r>
+              <a:rPr sz="1400">
+                <a:solidFill>
+                  <a:srgbClr val="3D5466"/>
+                </a:solidFill>
+                <a:latin typeface="Arial"/>
+              </a:rPr>
+              <a:t>▸  Befüllen Sie die fünf Bausteine der Terminmappe – verdichtet, nicht vollständig (AB-2).</a:t>
+            </a:r>
+          </a:p>
+          <a:p>
+            <a:pPr marL="190500" indent="-190500">
+              <a:spcBef>
+                <a:spcPts val="400"/>
+              </a:spcBef>
+              <a:spcAft>
+                <a:spcPts val="200"/>
+              </a:spcAft>
+            </a:pPr>
+            <a:r>
+              <a:rPr sz="1400">
+                <a:solidFill>
+                  <a:srgbClr val="3D5466"/>
+                </a:solidFill>
+                <a:latin typeface="Arial"/>
+              </a:rPr>
+              <a:t>▸  Identifizieren Sie die Anlässe aus dem Fall und markieren Sie sie (AB-3).</a:t>
+            </a:r>
+          </a:p>
+          <a:p>
+            <a:pPr marL="190500" indent="-190500">
+              <a:spcBef>
+                <a:spcPts val="400"/>
+              </a:spcBef>
+              <a:spcAft>
+                <a:spcPts val="200"/>
+              </a:spcAft>
+            </a:pPr>
+            <a:r>
+              <a:rPr sz="1400">
+                <a:solidFill>
+                  <a:srgbClr val="3D5466"/>
+                </a:solidFill>
+                <a:latin typeface="Arial"/>
+              </a:rPr>
+              <a:t>▸  Stellen Sie einen Nachbereitungsplan mit Wiedervorlagen auf (AB-4) – Karte AB-5 als Werkzeug.</a:t>
+            </a:r>
+          </a:p>
+        </p:txBody>
+      </p:sp>
+      <p:sp>
+        <p:nvSpPr>
+          <p:cNvPr id="9" name="Rectangle 8"/>
+          <p:cNvSpPr/>
+          <p:nvPr/>
+        </p:nvSpPr>
+        <p:spPr>
+          <a:xfrm>
+            <a:off x="685800" y="5486400"/>
+            <a:ext cx="10817352" cy="640080"/>
+          </a:xfrm>
+          <a:prstGeom prst="rect">
+            <a:avLst/>
+          </a:prstGeom>
+          <a:solidFill>
+            <a:srgbClr val="1F2C56"/>
+          </a:solidFill>
+          <a:ln>
+            <a:noFill/>
+          </a:ln>
+        </p:spPr>
+        <p:style>
+          <a:lnRef idx="1">
+            <a:schemeClr val="accent1"/>
+          </a:lnRef>
+          <a:fillRef idx="3">
+            <a:schemeClr val="accent1"/>
+          </a:fillRef>
+          <a:effectRef idx="2">
+            <a:schemeClr val="accent1"/>
+          </a:effectRef>
+          <a:fontRef idx="minor">
+            <a:schemeClr val="lt1"/>
+          </a:fontRef>
+        </p:style>
+        <p:txBody>
+          <a:bodyPr rtlCol="0" anchor="ctr"/>
+          <a:lstStyle/>
+          <a:p>
+            <a:pPr algn="ctr"/>
+          </a:p>
+        </p:txBody>
+      </p:sp>
+      <p:sp>
+        <p:nvSpPr>
+          <p:cNvPr id="10" name="TextBox 9"/>
+          <p:cNvSpPr txBox="1"/>
+          <p:nvPr/>
+        </p:nvSpPr>
+        <p:spPr>
+          <a:xfrm>
+            <a:off x="868680" y="5596128"/>
+            <a:ext cx="10451592" cy="457200"/>
+          </a:xfrm>
+          <a:prstGeom prst="rect">
+            <a:avLst/>
+          </a:prstGeom>
+          <a:noFill/>
+        </p:spPr>
+        <p:txBody>
+          <a:bodyPr wrap="square">
+            <a:spAutoFit/>
+          </a:bodyPr>
+          <a:lstStyle/>
+          <a:p>
+            <a:pPr algn="l"/>
+            <a:r>
+              <a:rPr sz="1300" b="1" i="0">
+                <a:solidFill>
+                  <a:srgbClr val="FFFFFF"/>
+                </a:solidFill>
+                <a:latin typeface="Arial"/>
+              </a:rPr>
+              <a:t>→  Bearbeitung im Teilnehmer-Workbook (Arbeitsblatt mit Ausfüllfeldern)</a:t>
+            </a:r>
+          </a:p>
+        </p:txBody>
+      </p:sp>
+      <p:sp>
+        <p:nvSpPr>
+          <p:cNvPr id="11" name="Rectangle 10"/>
+          <p:cNvSpPr/>
+          <p:nvPr/>
+        </p:nvSpPr>
+        <p:spPr>
+          <a:xfrm>
+            <a:off x="0" y="6510528"/>
+            <a:ext cx="12188952" cy="347472"/>
+          </a:xfrm>
+          <a:prstGeom prst="rect">
+            <a:avLst/>
+          </a:prstGeom>
+          <a:solidFill>
+            <a:srgbClr val="0A1937"/>
+          </a:solidFill>
+          <a:ln>
+            <a:noFill/>
+          </a:ln>
+        </p:spPr>
+        <p:style>
+          <a:lnRef idx="1">
+            <a:schemeClr val="accent1"/>
+          </a:lnRef>
+          <a:fillRef idx="3">
+            <a:schemeClr val="accent1"/>
+          </a:fillRef>
+          <a:effectRef idx="2">
+            <a:schemeClr val="accent1"/>
+          </a:effectRef>
+          <a:fontRef idx="minor">
+            <a:schemeClr val="lt1"/>
+          </a:fontRef>
+        </p:style>
+        <p:txBody>
+          <a:bodyPr rtlCol="0" anchor="ctr"/>
+          <a:lstStyle/>
+          <a:p>
+            <a:pPr algn="ctr"/>
+          </a:p>
+        </p:txBody>
+      </p:sp>
+      <p:sp>
+        <p:nvSpPr>
+          <p:cNvPr id="12" name="TextBox 11"/>
+          <p:cNvSpPr txBox="1"/>
+          <p:nvPr/>
+        </p:nvSpPr>
+        <p:spPr>
+          <a:xfrm>
+            <a:off x="685800" y="6583680"/>
+            <a:ext cx="6490411" cy="256032"/>
+          </a:xfrm>
+          <a:prstGeom prst="rect">
+            <a:avLst/>
+          </a:prstGeom>
+          <a:noFill/>
+        </p:spPr>
+        <p:txBody>
+          <a:bodyPr wrap="none">
+            <a:spAutoFit/>
+          </a:bodyPr>
+          <a:lstStyle/>
+          <a:p>
+            <a:pPr algn="l"/>
+            <a:r>
+              <a:rPr sz="700">
+                <a:solidFill>
+                  <a:srgbClr val="A0B4D2"/>
+                </a:solidFill>
+                <a:latin typeface="Consolas"/>
+              </a:rPr>
+              <a:t>FKB Campus  ·  VA06</a:t>
+            </a:r>
+          </a:p>
+        </p:txBody>
+      </p:sp>
+    </p:spTree>
+  </p:cSld>
+  <p:clrMapOvr>
+    <a:masterClrMapping/>
+  </p:clrMapOvr>
+</p:sld>
+</file>
+
+<file path=ppt/slides/slide14.xml><?xml version="1.0" encoding="utf-8"?>
+<p:sld xmlns:a="http://schemas.openxmlformats.org/drawingml/2006/main" xmlns:p="http://schemas.openxmlformats.org/presentationml/2006/main" xmlns:r="http://schemas.openxmlformats.org/officeDocument/2006/relationships">
+  <p:cSld>
+    <p:spTree>
+      <p:nvGrpSpPr>
+        <p:cNvPr id="1" name=""/>
+        <p:cNvGrpSpPr/>
+        <p:nvPr/>
+      </p:nvGrpSpPr>
+      <p:grpSpPr/>
+      <p:sp>
+        <p:nvSpPr>
+          <p:cNvPr id="2" name="Rectangle 1"/>
+          <p:cNvSpPr/>
+          <p:nvPr/>
+        </p:nvSpPr>
+        <p:spPr>
+          <a:xfrm>
+            <a:off x="0" y="0"/>
+            <a:ext cx="12188952" cy="6858000"/>
+          </a:xfrm>
+          <a:prstGeom prst="rect">
+            <a:avLst/>
+          </a:prstGeom>
+          <a:solidFill>
+            <a:srgbClr val="EDEDF3"/>
+          </a:solidFill>
+          <a:ln>
+            <a:noFill/>
+          </a:ln>
+        </p:spPr>
+        <p:style>
+          <a:lnRef idx="1">
+            <a:schemeClr val="accent1"/>
+          </a:lnRef>
+          <a:fillRef idx="3">
+            <a:schemeClr val="accent1"/>
+          </a:fillRef>
+          <a:effectRef idx="2">
+            <a:schemeClr val="accent1"/>
+          </a:effectRef>
+          <a:fontRef idx="minor">
+            <a:schemeClr val="lt1"/>
+          </a:fontRef>
+        </p:style>
+        <p:txBody>
+          <a:bodyPr rtlCol="0" anchor="ctr"/>
+          <a:lstStyle/>
+          <a:p>
+            <a:pPr algn="ctr"/>
+          </a:p>
+        </p:txBody>
+      </p:sp>
+      <p:sp>
+        <p:nvSpPr>
+          <p:cNvPr id="3" name="Rectangle 2"/>
+          <p:cNvSpPr/>
+          <p:nvPr/>
+        </p:nvSpPr>
+        <p:spPr>
+          <a:xfrm>
+            <a:off x="0" y="0"/>
+            <a:ext cx="12188952" cy="50292"/>
+          </a:xfrm>
+          <a:prstGeom prst="rect">
+            <a:avLst/>
+          </a:prstGeom>
+          <a:solidFill>
+            <a:srgbClr val="1F2C56"/>
+          </a:solidFill>
+          <a:ln>
+            <a:noFill/>
+          </a:ln>
+        </p:spPr>
+        <p:style>
+          <a:lnRef idx="1">
+            <a:schemeClr val="accent1"/>
+          </a:lnRef>
+          <a:fillRef idx="3">
+            <a:schemeClr val="accent1"/>
+          </a:fillRef>
+          <a:effectRef idx="2">
+            <a:schemeClr val="accent1"/>
+          </a:effectRef>
+          <a:fontRef idx="minor">
+            <a:schemeClr val="lt1"/>
+          </a:fontRef>
+        </p:style>
+        <p:txBody>
+          <a:bodyPr rtlCol="0" anchor="ctr"/>
+          <a:lstStyle/>
+          <a:p>
+            <a:pPr algn="ctr"/>
+          </a:p>
+        </p:txBody>
+      </p:sp>
+      <p:sp>
+        <p:nvSpPr>
+          <p:cNvPr id="4" name="TextBox 3"/>
+          <p:cNvSpPr txBox="1"/>
+          <p:nvPr/>
+        </p:nvSpPr>
+        <p:spPr>
+          <a:xfrm>
+            <a:off x="685800" y="109728"/>
+            <a:ext cx="10817352" cy="228600"/>
+          </a:xfrm>
+          <a:prstGeom prst="rect">
+            <a:avLst/>
+          </a:prstGeom>
+          <a:noFill/>
+        </p:spPr>
+        <p:txBody>
+          <a:bodyPr wrap="none">
+            <a:spAutoFit/>
+          </a:bodyPr>
+          <a:lstStyle/>
+          <a:p>
+            <a:pPr algn="l"/>
+            <a:r>
+              <a:rPr sz="750">
+                <a:solidFill>
+                  <a:srgbClr val="78808C"/>
+                </a:solidFill>
+                <a:latin typeface="Consolas"/>
+              </a:rPr>
+              <a:t>VA06  ·  INHALT</a:t>
+            </a:r>
+          </a:p>
+        </p:txBody>
+      </p:sp>
+      <p:sp>
+        <p:nvSpPr>
+          <p:cNvPr id="5" name="Rectangle 4"/>
+          <p:cNvSpPr/>
+          <p:nvPr/>
+        </p:nvSpPr>
+        <p:spPr>
+          <a:xfrm>
+            <a:off x="0" y="1234440"/>
+            <a:ext cx="12188952" cy="12700"/>
+          </a:xfrm>
+          <a:prstGeom prst="rect">
+            <a:avLst/>
+          </a:prstGeom>
+          <a:solidFill>
+            <a:srgbClr val="D8DFE4"/>
+          </a:solidFill>
+          <a:ln>
+            <a:noFill/>
+          </a:ln>
+        </p:spPr>
+        <p:style>
+          <a:lnRef idx="1">
+            <a:schemeClr val="accent1"/>
+          </a:lnRef>
+          <a:fillRef idx="3">
+            <a:schemeClr val="accent1"/>
+          </a:fillRef>
+          <a:effectRef idx="2">
+            <a:schemeClr val="accent1"/>
+          </a:effectRef>
+          <a:fontRef idx="minor">
+            <a:schemeClr val="lt1"/>
+          </a:fontRef>
+        </p:style>
+        <p:txBody>
+          <a:bodyPr rtlCol="0" anchor="ctr"/>
+          <a:lstStyle/>
+          <a:p>
+            <a:pPr algn="ctr"/>
+          </a:p>
+        </p:txBody>
+      </p:sp>
+      <p:sp>
+        <p:nvSpPr>
+          <p:cNvPr id="6" name="Rectangle 5"/>
+          <p:cNvSpPr/>
+          <p:nvPr/>
+        </p:nvSpPr>
+        <p:spPr>
+          <a:xfrm>
+            <a:off x="685800" y="502920"/>
+            <a:ext cx="36576" cy="658368"/>
+          </a:xfrm>
+          <a:prstGeom prst="rect">
+            <a:avLst/>
+          </a:prstGeom>
+          <a:solidFill>
+            <a:srgbClr val="D9C089"/>
+          </a:solidFill>
+          <a:ln>
+            <a:noFill/>
+          </a:ln>
+        </p:spPr>
+        <p:style>
+          <a:lnRef idx="1">
+            <a:schemeClr val="accent1"/>
+          </a:lnRef>
+          <a:fillRef idx="3">
+            <a:schemeClr val="accent1"/>
+          </a:fillRef>
+          <a:effectRef idx="2">
+            <a:schemeClr val="accent1"/>
+          </a:effectRef>
+          <a:fontRef idx="minor">
+            <a:schemeClr val="lt1"/>
+          </a:fontRef>
+        </p:style>
+        <p:txBody>
+          <a:bodyPr rtlCol="0" anchor="ctr"/>
+          <a:lstStyle/>
+          <a:p>
+            <a:pPr algn="ctr"/>
+          </a:p>
+        </p:txBody>
+      </p:sp>
+      <p:sp>
+        <p:nvSpPr>
+          <p:cNvPr id="7" name="TextBox 6"/>
+          <p:cNvSpPr txBox="1"/>
+          <p:nvPr/>
+        </p:nvSpPr>
+        <p:spPr>
+          <a:xfrm>
+            <a:off x="813816" y="502920"/>
+            <a:ext cx="10634472" cy="685800"/>
+          </a:xfrm>
+          <a:prstGeom prst="rect">
+            <a:avLst/>
+          </a:prstGeom>
+          <a:noFill/>
+        </p:spPr>
+        <p:txBody>
+          <a:bodyPr wrap="square">
+            <a:spAutoFit/>
+          </a:bodyPr>
+          <a:lstStyle/>
+          <a:p>
+            <a:pPr algn="l"/>
+            <a:r>
+              <a:rPr sz="2400" b="1" i="0">
+                <a:solidFill>
+                  <a:srgbClr val="1F2C56"/>
+                </a:solidFill>
+                <a:latin typeface="Arial"/>
+              </a:rPr>
+              <a:t>Prinzip dieses Moduls</a:t>
+            </a:r>
+          </a:p>
+        </p:txBody>
+      </p:sp>
+      <p:sp>
+        <p:nvSpPr>
+          <p:cNvPr id="8" name="TextBox 7"/>
+          <p:cNvSpPr txBox="1"/>
+          <p:nvPr/>
+        </p:nvSpPr>
+        <p:spPr>
+          <a:xfrm>
+            <a:off x="685800" y="1417320"/>
+            <a:ext cx="10817352" cy="4892040"/>
+          </a:xfrm>
+          <a:prstGeom prst="rect">
+            <a:avLst/>
+          </a:prstGeom>
+          <a:noFill/>
+        </p:spPr>
+        <p:txBody>
+          <a:bodyPr wrap="square" anchor="ctr">
+            <a:spAutoFit/>
+          </a:bodyPr>
+          <a:lstStyle/>
+          <a:p>
+            <a:pPr marL="177800" indent="-177800">
+              <a:spcBef>
+                <a:spcPts val="600"/>
+              </a:spcBef>
+              <a:spcAft>
+                <a:spcPts val="200"/>
+              </a:spcAft>
+            </a:pPr>
+            <a:r>
+              <a:rPr sz="1200" i="1">
+                <a:solidFill>
+                  <a:srgbClr val="3D5466"/>
+                </a:solidFill>
+                <a:latin typeface="Arial"/>
+              </a:rPr>
+              <a:t>→  Die beste Vorbereitung ist die, die der Berater nicht mehr machen muss.</a:t>
+            </a:r>
+          </a:p>
+          <a:p>
+            <a:pPr marL="190500" indent="-190500">
+              <a:spcBef>
+                <a:spcPts val="400"/>
+              </a:spcBef>
+              <a:spcAft>
+                <a:spcPts val="200"/>
+              </a:spcAft>
+            </a:pPr>
+            <a:r>
+              <a:rPr sz="1300">
+                <a:solidFill>
+                  <a:srgbClr val="3D5466"/>
+                </a:solidFill>
+                <a:latin typeface="Arial"/>
+              </a:rPr>
+              <a:t>▸  Eine entscheidungsreife Terminmappe entlastet den Berater und macht den Innendienst unsichtbar wirksam.</a:t>
+            </a:r>
+          </a:p>
+        </p:txBody>
+      </p:sp>
+      <p:sp>
+        <p:nvSpPr>
+          <p:cNvPr id="9" name="Rectangle 8"/>
+          <p:cNvSpPr/>
+          <p:nvPr/>
+        </p:nvSpPr>
+        <p:spPr>
+          <a:xfrm>
+            <a:off x="0" y="6510528"/>
+            <a:ext cx="12188952" cy="347472"/>
+          </a:xfrm>
+          <a:prstGeom prst="rect">
+            <a:avLst/>
+          </a:prstGeom>
+          <a:solidFill>
+            <a:srgbClr val="0A1937"/>
+          </a:solidFill>
+          <a:ln>
+            <a:noFill/>
+          </a:ln>
+        </p:spPr>
+        <p:style>
+          <a:lnRef idx="1">
+            <a:schemeClr val="accent1"/>
+          </a:lnRef>
+          <a:fillRef idx="3">
+            <a:schemeClr val="accent1"/>
+          </a:fillRef>
+          <a:effectRef idx="2">
+            <a:schemeClr val="accent1"/>
+          </a:effectRef>
+          <a:fontRef idx="minor">
+            <a:schemeClr val="lt1"/>
+          </a:fontRef>
+        </p:style>
+        <p:txBody>
+          <a:bodyPr rtlCol="0" anchor="ctr"/>
+          <a:lstStyle/>
+          <a:p>
+            <a:pPr algn="ctr"/>
+          </a:p>
+        </p:txBody>
+      </p:sp>
+      <p:sp>
+        <p:nvSpPr>
+          <p:cNvPr id="10" name="TextBox 9"/>
+          <p:cNvSpPr txBox="1"/>
+          <p:nvPr/>
+        </p:nvSpPr>
+        <p:spPr>
+          <a:xfrm>
+            <a:off x="685800" y="6583680"/>
+            <a:ext cx="6490411" cy="256032"/>
+          </a:xfrm>
+          <a:prstGeom prst="rect">
+            <a:avLst/>
+          </a:prstGeom>
+          <a:noFill/>
+        </p:spPr>
+        <p:txBody>
+          <a:bodyPr wrap="none">
+            <a:spAutoFit/>
+          </a:bodyPr>
+          <a:lstStyle/>
+          <a:p>
+            <a:pPr algn="l"/>
+            <a:r>
+              <a:rPr sz="700">
+                <a:solidFill>
+                  <a:srgbClr val="A0B4D2"/>
+                </a:solidFill>
+                <a:latin typeface="Consolas"/>
+              </a:rPr>
+              <a:t>FKB Campus  ·  VA06</a:t>
+            </a:r>
+          </a:p>
+        </p:txBody>
+      </p:sp>
+    </p:spTree>
+  </p:cSld>
+  <p:clrMapOvr>
+    <a:masterClrMapping/>
+  </p:clrMapOvr>
+</p:sld>
+</file>
+
+<file path=ppt/slides/slide15.xml><?xml version="1.0" encoding="utf-8"?>
+<p:sld xmlns:a="http://schemas.openxmlformats.org/drawingml/2006/main" xmlns:p="http://schemas.openxmlformats.org/presentationml/2006/main" xmlns:r="http://schemas.openxmlformats.org/officeDocument/2006/relationships">
+  <p:cSld>
+    <p:spTree>
+      <p:nvGrpSpPr>
+        <p:cNvPr id="1" name=""/>
+        <p:cNvGrpSpPr/>
+        <p:nvPr/>
+      </p:nvGrpSpPr>
+      <p:grpSpPr/>
+      <p:sp>
+        <p:nvSpPr>
+          <p:cNvPr id="2" name="Rectangle 1"/>
+          <p:cNvSpPr/>
+          <p:nvPr/>
+        </p:nvSpPr>
+        <p:spPr>
+          <a:xfrm>
+            <a:off x="0" y="0"/>
+            <a:ext cx="12188952" cy="6858000"/>
+          </a:xfrm>
+          <a:prstGeom prst="rect">
+            <a:avLst/>
+          </a:prstGeom>
+          <a:solidFill>
+            <a:srgbClr val="EDEDF3"/>
+          </a:solidFill>
+          <a:ln>
+            <a:noFill/>
+          </a:ln>
+        </p:spPr>
+        <p:style>
+          <a:lnRef idx="1">
+            <a:schemeClr val="accent1"/>
+          </a:lnRef>
+          <a:fillRef idx="3">
+            <a:schemeClr val="accent1"/>
+          </a:fillRef>
+          <a:effectRef idx="2">
+            <a:schemeClr val="accent1"/>
+          </a:effectRef>
+          <a:fontRef idx="minor">
+            <a:schemeClr val="lt1"/>
+          </a:fontRef>
+        </p:style>
+        <p:txBody>
+          <a:bodyPr rtlCol="0" anchor="ctr"/>
+          <a:lstStyle/>
+          <a:p>
+            <a:pPr algn="ctr"/>
+          </a:p>
+        </p:txBody>
+      </p:sp>
+      <p:sp>
+        <p:nvSpPr>
+          <p:cNvPr id="3" name="Rectangle 2"/>
+          <p:cNvSpPr/>
+          <p:nvPr/>
+        </p:nvSpPr>
+        <p:spPr>
+          <a:xfrm>
+            <a:off x="0" y="0"/>
+            <a:ext cx="12188952" cy="50292"/>
+          </a:xfrm>
+          <a:prstGeom prst="rect">
+            <a:avLst/>
+          </a:prstGeom>
+          <a:solidFill>
+            <a:srgbClr val="1F2C56"/>
+          </a:solidFill>
+          <a:ln>
+            <a:noFill/>
+          </a:ln>
+        </p:spPr>
+        <p:style>
+          <a:lnRef idx="1">
+            <a:schemeClr val="accent1"/>
+          </a:lnRef>
+          <a:fillRef idx="3">
+            <a:schemeClr val="accent1"/>
+          </a:fillRef>
+          <a:effectRef idx="2">
+            <a:schemeClr val="accent1"/>
+          </a:effectRef>
+          <a:fontRef idx="minor">
+            <a:schemeClr val="lt1"/>
+          </a:fontRef>
+        </p:style>
+        <p:txBody>
+          <a:bodyPr rtlCol="0" anchor="ctr"/>
+          <a:lstStyle/>
+          <a:p>
+            <a:pPr algn="ctr"/>
+          </a:p>
+        </p:txBody>
+      </p:sp>
+      <p:sp>
+        <p:nvSpPr>
+          <p:cNvPr id="4" name="TextBox 3"/>
+          <p:cNvSpPr txBox="1"/>
+          <p:nvPr/>
+        </p:nvSpPr>
+        <p:spPr>
+          <a:xfrm>
+            <a:off x="685800" y="109728"/>
+            <a:ext cx="10817352" cy="228600"/>
+          </a:xfrm>
+          <a:prstGeom prst="rect">
+            <a:avLst/>
+          </a:prstGeom>
+          <a:noFill/>
+        </p:spPr>
+        <p:txBody>
+          <a:bodyPr wrap="none">
+            <a:spAutoFit/>
+          </a:bodyPr>
+          <a:lstStyle/>
+          <a:p>
+            <a:pPr algn="l"/>
+            <a:r>
+              <a:rPr sz="750">
+                <a:solidFill>
+                  <a:srgbClr val="78808C"/>
+                </a:solidFill>
+                <a:latin typeface="Consolas"/>
+              </a:rPr>
+              <a:t>VA06  ·  INHALT</a:t>
+            </a:r>
+          </a:p>
+        </p:txBody>
+      </p:sp>
+      <p:sp>
+        <p:nvSpPr>
+          <p:cNvPr id="5" name="Rectangle 4"/>
+          <p:cNvSpPr/>
+          <p:nvPr/>
+        </p:nvSpPr>
+        <p:spPr>
+          <a:xfrm>
+            <a:off x="0" y="1234440"/>
+            <a:ext cx="12188952" cy="12700"/>
+          </a:xfrm>
+          <a:prstGeom prst="rect">
+            <a:avLst/>
+          </a:prstGeom>
+          <a:solidFill>
+            <a:srgbClr val="D8DFE4"/>
+          </a:solidFill>
+          <a:ln>
+            <a:noFill/>
+          </a:ln>
+        </p:spPr>
+        <p:style>
+          <a:lnRef idx="1">
+            <a:schemeClr val="accent1"/>
+          </a:lnRef>
+          <a:fillRef idx="3">
+            <a:schemeClr val="accent1"/>
+          </a:fillRef>
+          <a:effectRef idx="2">
+            <a:schemeClr val="accent1"/>
+          </a:effectRef>
+          <a:fontRef idx="minor">
+            <a:schemeClr val="lt1"/>
+          </a:fontRef>
+        </p:style>
+        <p:txBody>
+          <a:bodyPr rtlCol="0" anchor="ctr"/>
+          <a:lstStyle/>
+          <a:p>
+            <a:pPr algn="ctr"/>
+          </a:p>
+        </p:txBody>
+      </p:sp>
+      <p:sp>
+        <p:nvSpPr>
+          <p:cNvPr id="6" name="Rectangle 5"/>
+          <p:cNvSpPr/>
+          <p:nvPr/>
+        </p:nvSpPr>
+        <p:spPr>
+          <a:xfrm>
+            <a:off x="685800" y="502920"/>
+            <a:ext cx="36576" cy="658368"/>
+          </a:xfrm>
+          <a:prstGeom prst="rect">
+            <a:avLst/>
+          </a:prstGeom>
+          <a:solidFill>
+            <a:srgbClr val="D9C089"/>
+          </a:solidFill>
+          <a:ln>
+            <a:noFill/>
+          </a:ln>
+        </p:spPr>
+        <p:style>
+          <a:lnRef idx="1">
+            <a:schemeClr val="accent1"/>
+          </a:lnRef>
+          <a:fillRef idx="3">
+            <a:schemeClr val="accent1"/>
+          </a:fillRef>
+          <a:effectRef idx="2">
+            <a:schemeClr val="accent1"/>
+          </a:effectRef>
+          <a:fontRef idx="minor">
+            <a:schemeClr val="lt1"/>
+          </a:fontRef>
+        </p:style>
+        <p:txBody>
+          <a:bodyPr rtlCol="0" anchor="ctr"/>
+          <a:lstStyle/>
+          <a:p>
+            <a:pPr algn="ctr"/>
+          </a:p>
+        </p:txBody>
+      </p:sp>
+      <p:sp>
+        <p:nvSpPr>
+          <p:cNvPr id="7" name="TextBox 6"/>
+          <p:cNvSpPr txBox="1"/>
+          <p:nvPr/>
+        </p:nvSpPr>
+        <p:spPr>
+          <a:xfrm>
+            <a:off x="813816" y="502920"/>
+            <a:ext cx="10634472" cy="685800"/>
+          </a:xfrm>
+          <a:prstGeom prst="rect">
+            <a:avLst/>
+          </a:prstGeom>
+          <a:noFill/>
+        </p:spPr>
+        <p:txBody>
+          <a:bodyPr wrap="square">
+            <a:spAutoFit/>
+          </a:bodyPr>
+          <a:lstStyle/>
+          <a:p>
+            <a:pPr algn="l"/>
+            <a:r>
+              <a:rPr sz="2400" b="1" i="0">
+                <a:solidFill>
+                  <a:srgbClr val="1F2C56"/>
+                </a:solidFill>
+                <a:latin typeface="Arial"/>
+              </a:rPr>
+              <a:t>Reflexionsfragen</a:t>
+            </a:r>
+          </a:p>
+        </p:txBody>
+      </p:sp>
+      <p:sp>
+        <p:nvSpPr>
+          <p:cNvPr id="8" name="TextBox 7"/>
+          <p:cNvSpPr txBox="1"/>
+          <p:nvPr/>
+        </p:nvSpPr>
+        <p:spPr>
+          <a:xfrm>
+            <a:off x="685800" y="1417320"/>
+            <a:ext cx="10817352" cy="4892040"/>
+          </a:xfrm>
+          <a:prstGeom prst="rect">
+            <a:avLst/>
+          </a:prstGeom>
+          <a:noFill/>
+        </p:spPr>
+        <p:txBody>
+          <a:bodyPr wrap="square" anchor="ctr">
+            <a:spAutoFit/>
+          </a:bodyPr>
+          <a:lstStyle/>
+          <a:p>
+            <a:pPr marL="190500" indent="-190500">
+              <a:spcBef>
+                <a:spcPts val="400"/>
+              </a:spcBef>
+              <a:spcAft>
+                <a:spcPts val="200"/>
+              </a:spcAft>
+            </a:pPr>
+            <a:r>
+              <a:rPr sz="1300">
+                <a:solidFill>
+                  <a:srgbClr val="3D5466"/>
+                </a:solidFill>
+                <a:latin typeface="Arial"/>
+              </a:rPr>
+              <a:t>▸  Welche Information landet bei Ihnen heute noch auf einem Zettel statt in der Mappe – und warum?</a:t>
+            </a:r>
+          </a:p>
+          <a:p>
+            <a:pPr marL="190500" indent="-190500">
+              <a:spcBef>
+                <a:spcPts val="400"/>
+              </a:spcBef>
+              <a:spcAft>
+                <a:spcPts val="200"/>
+              </a:spcAft>
+            </a:pPr>
+            <a:r>
+              <a:rPr sz="1300">
+                <a:solidFill>
+                  <a:srgbClr val="3D5466"/>
+                </a:solidFill>
+                <a:latin typeface="Arial"/>
+              </a:rPr>
+              <a:t>▸  Welche Kundenandeutung ist Ihnen schon einmal verloren gegangen?</a:t>
+            </a:r>
+          </a:p>
+          <a:p>
+            <a:pPr marL="190500" indent="-190500">
+              <a:spcBef>
+                <a:spcPts val="400"/>
+              </a:spcBef>
+              <a:spcAft>
+                <a:spcPts val="200"/>
+              </a:spcAft>
+            </a:pPr>
+            <a:r>
+              <a:rPr sz="1300">
+                <a:solidFill>
+                  <a:srgbClr val="3D5466"/>
+                </a:solidFill>
+                <a:latin typeface="Arial"/>
+              </a:rPr>
+              <a:t>▸  Was würde der Berater weglassen, wenn er Ihre letzte Mappe sähe – und was ergänzen?</a:t>
+            </a:r>
+          </a:p>
+        </p:txBody>
+      </p:sp>
+      <p:sp>
+        <p:nvSpPr>
+          <p:cNvPr id="9" name="Rectangle 8"/>
+          <p:cNvSpPr/>
+          <p:nvPr/>
+        </p:nvSpPr>
+        <p:spPr>
+          <a:xfrm>
+            <a:off x="0" y="6510528"/>
+            <a:ext cx="12188952" cy="347472"/>
+          </a:xfrm>
+          <a:prstGeom prst="rect">
+            <a:avLst/>
+          </a:prstGeom>
+          <a:solidFill>
+            <a:srgbClr val="0A1937"/>
+          </a:solidFill>
+          <a:ln>
+            <a:noFill/>
+          </a:ln>
+        </p:spPr>
+        <p:style>
+          <a:lnRef idx="1">
+            <a:schemeClr val="accent1"/>
+          </a:lnRef>
+          <a:fillRef idx="3">
+            <a:schemeClr val="accent1"/>
+          </a:fillRef>
+          <a:effectRef idx="2">
+            <a:schemeClr val="accent1"/>
+          </a:effectRef>
+          <a:fontRef idx="minor">
+            <a:schemeClr val="lt1"/>
+          </a:fontRef>
+        </p:style>
+        <p:txBody>
+          <a:bodyPr rtlCol="0" anchor="ctr"/>
+          <a:lstStyle/>
+          <a:p>
+            <a:pPr algn="ctr"/>
+          </a:p>
+        </p:txBody>
+      </p:sp>
+      <p:sp>
+        <p:nvSpPr>
+          <p:cNvPr id="10" name="TextBox 9"/>
+          <p:cNvSpPr txBox="1"/>
+          <p:nvPr/>
+        </p:nvSpPr>
+        <p:spPr>
+          <a:xfrm>
+            <a:off x="685800" y="6583680"/>
+            <a:ext cx="6490411" cy="256032"/>
+          </a:xfrm>
+          <a:prstGeom prst="rect">
+            <a:avLst/>
+          </a:prstGeom>
+          <a:noFill/>
+        </p:spPr>
+        <p:txBody>
+          <a:bodyPr wrap="none">
+            <a:spAutoFit/>
+          </a:bodyPr>
+          <a:lstStyle/>
+          <a:p>
+            <a:pPr algn="l"/>
+            <a:r>
+              <a:rPr sz="700">
+                <a:solidFill>
+                  <a:srgbClr val="A0B4D2"/>
+                </a:solidFill>
+                <a:latin typeface="Consolas"/>
+              </a:rPr>
+              <a:t>FKB Campus  ·  VA06</a:t>
+            </a:r>
+          </a:p>
+        </p:txBody>
+      </p:sp>
+    </p:spTree>
+  </p:cSld>
+  <p:clrMapOvr>
+    <a:masterClrMapping/>
+  </p:clrMapOvr>
+</p:sld>
+</file>
+
 <file path=ppt/slides/slide2.xml><?xml version="1.0" encoding="utf-8"?>
 <p:sld xmlns:a="http://schemas.openxmlformats.org/drawingml/2006/main" xmlns:p="http://schemas.openxmlformats.org/presentationml/2006/main" xmlns:r="http://schemas.openxmlformats.org/officeDocument/2006/relationships">
   <p:cSld>
@@ -5759,7 +8672,7 @@
             <a:avLst/>
           </a:prstGeom>
           <a:solidFill>
-            <a:srgbClr val="EDEDF3"/>
+            <a:srgbClr val="1F2C56"/>
           </a:solidFill>
           <a:ln>
             <a:noFill/>
@@ -5789,57 +8702,14 @@
       </p:sp>
       <p:sp>
         <p:nvSpPr>
-          <p:cNvPr id="3" name="Rectangle 2"/>
-          <p:cNvSpPr/>
-          <p:nvPr/>
-        </p:nvSpPr>
-        <p:spPr>
-          <a:xfrm>
-            <a:off x="0" y="0"/>
-            <a:ext cx="12188952" cy="50292"/>
-          </a:xfrm>
-          <a:prstGeom prst="rect">
-            <a:avLst/>
-          </a:prstGeom>
-          <a:solidFill>
-            <a:srgbClr val="1F2C56"/>
-          </a:solidFill>
-          <a:ln>
-            <a:noFill/>
-          </a:ln>
-        </p:spPr>
-        <p:style>
-          <a:lnRef idx="1">
-            <a:schemeClr val="accent1"/>
-          </a:lnRef>
-          <a:fillRef idx="3">
-            <a:schemeClr val="accent1"/>
-          </a:fillRef>
-          <a:effectRef idx="2">
-            <a:schemeClr val="accent1"/>
-          </a:effectRef>
-          <a:fontRef idx="minor">
-            <a:schemeClr val="lt1"/>
-          </a:fontRef>
-        </p:style>
-        <p:txBody>
-          <a:bodyPr rtlCol="0" anchor="ctr"/>
-          <a:lstStyle/>
-          <a:p>
-            <a:pPr algn="ctr"/>
-          </a:p>
-        </p:txBody>
-      </p:sp>
-      <p:sp>
-        <p:nvSpPr>
-          <p:cNvPr id="4" name="TextBox 3"/>
+          <p:cNvPr id="3" name="TextBox 2"/>
           <p:cNvSpPr txBox="1"/>
           <p:nvPr/>
         </p:nvSpPr>
         <p:spPr>
           <a:xfrm>
-            <a:off x="685800" y="109728"/>
-            <a:ext cx="10817352" cy="228600"/>
+            <a:off x="685800" y="2377440"/>
+            <a:ext cx="10817352" cy="365760"/>
           </a:xfrm>
           <a:prstGeom prst="rect">
             <a:avLst/>
@@ -5854,70 +8724,27 @@
           <a:p>
             <a:pPr algn="l"/>
             <a:r>
-              <a:rPr sz="750">
-                <a:solidFill>
-                  <a:srgbClr val="78808C"/>
+              <a:rPr sz="1200">
+                <a:solidFill>
+                  <a:srgbClr val="D9C089"/>
                 </a:solidFill>
                 <a:latin typeface="Consolas"/>
               </a:rPr>
-              <a:t>VA06  ·  INHALT</a:t>
-            </a:r>
-          </a:p>
-        </p:txBody>
-      </p:sp>
-      <p:sp>
-        <p:nvSpPr>
-          <p:cNvPr id="5" name="Rectangle 4"/>
+              <a:t>00:05–00:15</a:t>
+            </a:r>
+          </a:p>
+        </p:txBody>
+      </p:sp>
+      <p:sp>
+        <p:nvSpPr>
+          <p:cNvPr id="4" name="Rectangle 3"/>
           <p:cNvSpPr/>
           <p:nvPr/>
         </p:nvSpPr>
         <p:spPr>
           <a:xfrm>
-            <a:off x="0" y="1234440"/>
-            <a:ext cx="12188952" cy="12700"/>
-          </a:xfrm>
-          <a:prstGeom prst="rect">
-            <a:avLst/>
-          </a:prstGeom>
-          <a:solidFill>
-            <a:srgbClr val="D8DFE4"/>
-          </a:solidFill>
-          <a:ln>
-            <a:noFill/>
-          </a:ln>
-        </p:spPr>
-        <p:style>
-          <a:lnRef idx="1">
-            <a:schemeClr val="accent1"/>
-          </a:lnRef>
-          <a:fillRef idx="3">
-            <a:schemeClr val="accent1"/>
-          </a:fillRef>
-          <a:effectRef idx="2">
-            <a:schemeClr val="accent1"/>
-          </a:effectRef>
-          <a:fontRef idx="minor">
-            <a:schemeClr val="lt1"/>
-          </a:fontRef>
-        </p:style>
-        <p:txBody>
-          <a:bodyPr rtlCol="0" anchor="ctr"/>
-          <a:lstStyle/>
-          <a:p>
-            <a:pPr algn="ctr"/>
-          </a:p>
-        </p:txBody>
-      </p:sp>
-      <p:sp>
-        <p:nvSpPr>
-          <p:cNvPr id="6" name="Rectangle 5"/>
-          <p:cNvSpPr/>
-          <p:nvPr/>
-        </p:nvSpPr>
-        <p:spPr>
-          <a:xfrm>
-            <a:off x="685800" y="502920"/>
-            <a:ext cx="36576" cy="658368"/>
+            <a:off x="685800" y="2788920"/>
+            <a:ext cx="548640" cy="38100"/>
           </a:xfrm>
           <a:prstGeom prst="rect">
             <a:avLst/>
@@ -5953,14 +8780,14 @@
       </p:sp>
       <p:sp>
         <p:nvSpPr>
-          <p:cNvPr id="7" name="TextBox 6"/>
+          <p:cNvPr id="5" name="TextBox 4"/>
           <p:cNvSpPr txBox="1"/>
           <p:nvPr/>
         </p:nvSpPr>
         <p:spPr>
           <a:xfrm>
-            <a:off x="813816" y="502920"/>
-            <a:ext cx="10634472" cy="685800"/>
+            <a:off x="685800" y="3017520"/>
+            <a:ext cx="10817352" cy="1463040"/>
           </a:xfrm>
           <a:prstGeom prst="rect">
             <a:avLst/>
@@ -5975,27 +8802,27 @@
           <a:p>
             <a:pPr algn="l"/>
             <a:r>
-              <a:rPr sz="2400" b="1" i="0">
-                <a:solidFill>
-                  <a:srgbClr val="1F2C56"/>
+              <a:rPr sz="4000" b="1" i="0">
+                <a:solidFill>
+                  <a:srgbClr val="FFFFFF"/>
                 </a:solidFill>
                 <a:latin typeface="Arial"/>
               </a:rPr>
-              <a:t>Theorie-Input: Was eine gute Vorbereitung leistet</a:t>
-            </a:r>
-          </a:p>
-        </p:txBody>
-      </p:sp>
-      <p:sp>
-        <p:nvSpPr>
-          <p:cNvPr id="8" name="TextBox 7"/>
+              <a:t>Theorie-Input 1</a:t>
+            </a:r>
+          </a:p>
+        </p:txBody>
+      </p:sp>
+      <p:sp>
+        <p:nvSpPr>
+          <p:cNvPr id="6" name="TextBox 5"/>
           <p:cNvSpPr txBox="1"/>
           <p:nvPr/>
         </p:nvSpPr>
         <p:spPr>
           <a:xfrm>
-            <a:off x="685800" y="1417320"/>
-            <a:ext cx="10817352" cy="4892040"/>
+            <a:off x="685800" y="4480560"/>
+            <a:ext cx="8653881" cy="1280160"/>
           </a:xfrm>
           <a:prstGeom prst="rect">
             <a:avLst/>
@@ -6003,84 +8830,34 @@
           <a:noFill/>
         </p:spPr>
         <p:txBody>
-          <a:bodyPr wrap="square" anchor="ctr">
+          <a:bodyPr wrap="square">
             <a:spAutoFit/>
           </a:bodyPr>
           <a:lstStyle/>
           <a:p>
-            <a:pPr marL="190500" indent="-190500">
-              <a:spcBef>
-                <a:spcPts val="400"/>
-              </a:spcBef>
-              <a:spcAft>
-                <a:spcPts val="200"/>
-              </a:spcAft>
-            </a:pPr>
-            <a:r>
-              <a:rPr sz="1300">
-                <a:solidFill>
-                  <a:srgbClr val="3D5466"/>
+            <a:pPr algn="l"/>
+            <a:r>
+              <a:rPr sz="1600" b="0" i="0">
+                <a:solidFill>
+                  <a:srgbClr val="C8D2E6"/>
                 </a:solidFill>
                 <a:latin typeface="Arial"/>
               </a:rPr>
-              <a:t>▸  Bausteine einer Terminmappe (Jahresgespräch):</a:t>
-            </a:r>
-          </a:p>
-        </p:txBody>
-      </p:sp>
-      <p:sp>
-        <p:nvSpPr>
-          <p:cNvPr id="9" name="Rectangle 8"/>
-          <p:cNvSpPr/>
-          <p:nvPr/>
-        </p:nvSpPr>
-        <p:spPr>
-          <a:xfrm>
-            <a:off x="0" y="6510528"/>
-            <a:ext cx="12188952" cy="347472"/>
-          </a:xfrm>
-          <a:prstGeom prst="rect">
-            <a:avLst/>
-          </a:prstGeom>
-          <a:solidFill>
-            <a:srgbClr val="0A1937"/>
-          </a:solidFill>
-          <a:ln>
-            <a:noFill/>
-          </a:ln>
-        </p:spPr>
-        <p:style>
-          <a:lnRef idx="1">
-            <a:schemeClr val="accent1"/>
-          </a:lnRef>
-          <a:fillRef idx="3">
-            <a:schemeClr val="accent1"/>
-          </a:fillRef>
-          <a:effectRef idx="2">
-            <a:schemeClr val="accent1"/>
-          </a:effectRef>
-          <a:fontRef idx="minor">
-            <a:schemeClr val="lt1"/>
-          </a:fontRef>
-        </p:style>
-        <p:txBody>
-          <a:bodyPr rtlCol="0" anchor="ctr"/>
-          <a:lstStyle/>
-          <a:p>
-            <a:pPr algn="ctr"/>
-          </a:p>
-        </p:txBody>
-      </p:sp>
-      <p:sp>
-        <p:nvSpPr>
-          <p:cNvPr id="10" name="TextBox 9"/>
+              <a:t>Was eine Terminmappe leisten muss – verdichten statt sammeln.</a:t>
+            </a:r>
+          </a:p>
+        </p:txBody>
+      </p:sp>
+      <p:sp>
+        <p:nvSpPr>
+          <p:cNvPr id="7" name="TextBox 6"/>
           <p:cNvSpPr txBox="1"/>
           <p:nvPr/>
         </p:nvSpPr>
         <p:spPr>
           <a:xfrm>
-            <a:off x="685800" y="6583680"/>
-            <a:ext cx="6490411" cy="256032"/>
+            <a:off x="685800" y="6355080"/>
+            <a:ext cx="10817352" cy="274320"/>
           </a:xfrm>
           <a:prstGeom prst="rect">
             <a:avLst/>
@@ -6097,7 +8874,7 @@
             <a:r>
               <a:rPr sz="700">
                 <a:solidFill>
-                  <a:srgbClr val="A0B4D2"/>
+                  <a:srgbClr val="8CA0C3"/>
                 </a:solidFill>
                 <a:latin typeface="Consolas"/>
               </a:rPr>
@@ -6240,7 +9017,7 @@
                 </a:solidFill>
                 <a:latin typeface="Consolas"/>
               </a:rPr>
-              <a:t>VA06  ·  ARBEITSBLATT</a:t>
+              <a:t>VA06  ·  INHALT</a:t>
             </a:r>
           </a:p>
         </p:txBody>
@@ -6361,7 +9138,7 @@
                 </a:solidFill>
                 <a:latin typeface="Arial"/>
               </a:rPr>
-              <a:t>Praxisfall: Jahresgespräch Handwerk Musterregion GmbH</a:t>
+              <a:t>Die Terminmappe: relevant statt vollständig</a:t>
             </a:r>
           </a:p>
         </p:txBody>
@@ -6374,8 +9151,8 @@
         </p:nvSpPr>
         <p:spPr>
           <a:xfrm>
-            <a:off x="685800" y="1554480"/>
-            <a:ext cx="10817352" cy="3840480"/>
+            <a:off x="685800" y="1417320"/>
+            <a:ext cx="10817352" cy="4892040"/>
           </a:xfrm>
           <a:prstGeom prst="rect">
             <a:avLst/>
@@ -6383,10 +9160,29 @@
           <a:noFill/>
         </p:spPr>
         <p:txBody>
-          <a:bodyPr wrap="square">
+          <a:bodyPr wrap="square" anchor="ctr">
             <a:spAutoFit/>
           </a:bodyPr>
           <a:lstStyle/>
+          <a:p>
+            <a:pPr marL="177800" indent="-177800">
+              <a:spcBef>
+                <a:spcPts val="600"/>
+              </a:spcBef>
+              <a:spcAft>
+                <a:spcPts val="200"/>
+              </a:spcAft>
+            </a:pPr>
+            <a:r>
+              <a:rPr sz="1200" i="1">
+                <a:solidFill>
+                  <a:srgbClr val="3D5466"/>
+                </a:solidFill>
+                <a:latin typeface="Arial"/>
+              </a:rPr>
+              <a:t>→  Eine gute Vorbereitung beantwortet eine Frage: Was braucht der Berater, um im Gespräch souverän und entscheidungsfähig zu sein?</a:t>
+            </a:r>
+          </a:p>
           <a:p>
             <a:pPr marL="190500" indent="-190500">
               <a:spcBef>
@@ -6397,13 +9193,13 @@
               </a:spcAft>
             </a:pPr>
             <a:r>
-              <a:rPr sz="1400">
+              <a:rPr sz="1300">
                 <a:solidFill>
                   <a:srgbClr val="3D5466"/>
                 </a:solidFill>
                 <a:latin typeface="Arial"/>
               </a:rPr>
-              <a:t>▸  Ausgangslage (anonymisiert)</a:t>
+              <a:t>▸  Fünf Bausteine: Kurzprofil, Engagementübersicht, Kennzahlen, offene Punkte, Agenda.</a:t>
             </a:r>
           </a:p>
           <a:p>
@@ -6416,13 +9212,13 @@
               </a:spcAft>
             </a:pPr>
             <a:r>
-              <a:rPr sz="1400">
+              <a:rPr sz="1300">
                 <a:solidFill>
                   <a:srgbClr val="3D5466"/>
                 </a:solidFill>
                 <a:latin typeface="Arial"/>
               </a:rPr>
-              <a:t>▸  Informationsbedarf bestimmen</a:t>
+              <a:t>▸  Vorauswahl und Verdichtung statt „Unterlagen kopieren" – die Mappe ist Entscheidungsinstrument, kein Archiv.</a:t>
             </a:r>
           </a:p>
           <a:p>
@@ -6435,51 +9231,13 @@
               </a:spcAft>
             </a:pPr>
             <a:r>
-              <a:rPr sz="1400">
+              <a:rPr sz="1300">
                 <a:solidFill>
                   <a:srgbClr val="3D5466"/>
                 </a:solidFill>
                 <a:latin typeface="Arial"/>
               </a:rPr>
-              <a:t>▸  Anleitung: Was braucht der Berater für dieses Gespräch wirklich? Wählen Sie aus und begründen Sie.</a:t>
-            </a:r>
-          </a:p>
-          <a:p>
-            <a:pPr marL="190500" indent="-190500">
-              <a:spcBef>
-                <a:spcPts val="400"/>
-              </a:spcBef>
-              <a:spcAft>
-                <a:spcPts val="200"/>
-              </a:spcAft>
-            </a:pPr>
-            <a:r>
-              <a:rPr sz="1400">
-                <a:solidFill>
-                  <a:srgbClr val="3D5466"/>
-                </a:solidFill>
-                <a:latin typeface="Arial"/>
-              </a:rPr>
-              <a:t>▸  Terminmappe zusammenstellen</a:t>
-            </a:r>
-          </a:p>
-          <a:p>
-            <a:pPr marL="190500" indent="-190500">
-              <a:spcBef>
-                <a:spcPts val="400"/>
-              </a:spcBef>
-              <a:spcAft>
-                <a:spcPts val="200"/>
-              </a:spcAft>
-            </a:pPr>
-            <a:r>
-              <a:rPr sz="1400">
-                <a:solidFill>
-                  <a:srgbClr val="3D5466"/>
-                </a:solidFill>
-                <a:latin typeface="Arial"/>
-              </a:rPr>
-              <a:t>▸  Anleitung: Füllen Sie die Bausteine der Terminmappe für den Fall.</a:t>
+              <a:t>▸  Die Agenda ist ein Vorschlag, keine Vorgabe; Erwartungen des Beraters aktiv klären, nicht vermuten.</a:t>
             </a:r>
           </a:p>
         </p:txBody>
@@ -6487,84 +9245,6 @@
       <p:sp>
         <p:nvSpPr>
           <p:cNvPr id="9" name="Rectangle 8"/>
-          <p:cNvSpPr/>
-          <p:nvPr/>
-        </p:nvSpPr>
-        <p:spPr>
-          <a:xfrm>
-            <a:off x="685800" y="5486400"/>
-            <a:ext cx="10817352" cy="640080"/>
-          </a:xfrm>
-          <a:prstGeom prst="rect">
-            <a:avLst/>
-          </a:prstGeom>
-          <a:solidFill>
-            <a:srgbClr val="1F2C56"/>
-          </a:solidFill>
-          <a:ln>
-            <a:noFill/>
-          </a:ln>
-        </p:spPr>
-        <p:style>
-          <a:lnRef idx="1">
-            <a:schemeClr val="accent1"/>
-          </a:lnRef>
-          <a:fillRef idx="3">
-            <a:schemeClr val="accent1"/>
-          </a:fillRef>
-          <a:effectRef idx="2">
-            <a:schemeClr val="accent1"/>
-          </a:effectRef>
-          <a:fontRef idx="minor">
-            <a:schemeClr val="lt1"/>
-          </a:fontRef>
-        </p:style>
-        <p:txBody>
-          <a:bodyPr rtlCol="0" anchor="ctr"/>
-          <a:lstStyle/>
-          <a:p>
-            <a:pPr algn="ctr"/>
-          </a:p>
-        </p:txBody>
-      </p:sp>
-      <p:sp>
-        <p:nvSpPr>
-          <p:cNvPr id="10" name="TextBox 9"/>
-          <p:cNvSpPr txBox="1"/>
-          <p:nvPr/>
-        </p:nvSpPr>
-        <p:spPr>
-          <a:xfrm>
-            <a:off x="868680" y="5596128"/>
-            <a:ext cx="10451592" cy="457200"/>
-          </a:xfrm>
-          <a:prstGeom prst="rect">
-            <a:avLst/>
-          </a:prstGeom>
-          <a:noFill/>
-        </p:spPr>
-        <p:txBody>
-          <a:bodyPr wrap="square">
-            <a:spAutoFit/>
-          </a:bodyPr>
-          <a:lstStyle/>
-          <a:p>
-            <a:pPr algn="l"/>
-            <a:r>
-              <a:rPr sz="1300" b="1" i="0">
-                <a:solidFill>
-                  <a:srgbClr val="FFFFFF"/>
-                </a:solidFill>
-                <a:latin typeface="Arial"/>
-              </a:rPr>
-              <a:t>→  Bearbeitung im Teilnehmer-Workbook (Arbeitsblatt mit Ausfüllfeldern)</a:t>
-            </a:r>
-          </a:p>
-        </p:txBody>
-      </p:sp>
-      <p:sp>
-        <p:nvSpPr>
-          <p:cNvPr id="11" name="Rectangle 10"/>
           <p:cNvSpPr/>
           <p:nvPr/>
         </p:nvSpPr>
@@ -6607,7 +9287,7 @@
       </p:sp>
       <p:sp>
         <p:nvSpPr>
-          <p:cNvPr id="12" name="TextBox 11"/>
+          <p:cNvPr id="10" name="TextBox 9"/>
           <p:cNvSpPr txBox="1"/>
           <p:nvPr/>
         </p:nvSpPr>
@@ -6673,7 +9353,7 @@
             <a:avLst/>
           </a:prstGeom>
           <a:solidFill>
-            <a:srgbClr val="EDEDF3"/>
+            <a:srgbClr val="FFFFFF"/>
           </a:solidFill>
           <a:ln>
             <a:noFill/>
@@ -6774,6 +9454,360 @@
                 </a:solidFill>
                 <a:latin typeface="Consolas"/>
               </a:rPr>
+              <a:t>VA06  ·  SCHAUBILD</a:t>
+            </a:r>
+          </a:p>
+        </p:txBody>
+      </p:sp>
+      <p:sp>
+        <p:nvSpPr>
+          <p:cNvPr id="5" name="TextBox 4"/>
+          <p:cNvSpPr txBox="1"/>
+          <p:nvPr/>
+        </p:nvSpPr>
+        <p:spPr>
+          <a:xfrm>
+            <a:off x="685800" y="502920"/>
+            <a:ext cx="10817352" cy="594360"/>
+          </a:xfrm>
+          <a:prstGeom prst="rect">
+            <a:avLst/>
+          </a:prstGeom>
+          <a:noFill/>
+        </p:spPr>
+        <p:txBody>
+          <a:bodyPr wrap="square">
+            <a:spAutoFit/>
+          </a:bodyPr>
+          <a:lstStyle/>
+          <a:p>
+            <a:pPr algn="l"/>
+            <a:r>
+              <a:rPr sz="2000" b="1" i="0">
+                <a:solidFill>
+                  <a:srgbClr val="1F2C56"/>
+                </a:solidFill>
+                <a:latin typeface="Arial"/>
+              </a:rPr>
+              <a:t>Die Terminmappe: verdichten statt sammeln</a:t>
+            </a:r>
+          </a:p>
+        </p:txBody>
+      </p:sp>
+      <p:sp>
+        <p:nvSpPr>
+          <p:cNvPr id="6" name="Rectangle 5"/>
+          <p:cNvSpPr/>
+          <p:nvPr/>
+        </p:nvSpPr>
+        <p:spPr>
+          <a:xfrm>
+            <a:off x="685800" y="1143000"/>
+            <a:ext cx="10817352" cy="25400"/>
+          </a:xfrm>
+          <a:prstGeom prst="rect">
+            <a:avLst/>
+          </a:prstGeom>
+          <a:solidFill>
+            <a:srgbClr val="D9C089"/>
+          </a:solidFill>
+          <a:ln>
+            <a:noFill/>
+          </a:ln>
+        </p:spPr>
+        <p:style>
+          <a:lnRef idx="1">
+            <a:schemeClr val="accent1"/>
+          </a:lnRef>
+          <a:fillRef idx="3">
+            <a:schemeClr val="accent1"/>
+          </a:fillRef>
+          <a:effectRef idx="2">
+            <a:schemeClr val="accent1"/>
+          </a:effectRef>
+          <a:fontRef idx="minor">
+            <a:schemeClr val="lt1"/>
+          </a:fontRef>
+        </p:style>
+        <p:txBody>
+          <a:bodyPr rtlCol="0" anchor="ctr"/>
+          <a:lstStyle/>
+          <a:p>
+            <a:pPr algn="ctr"/>
+          </a:p>
+        </p:txBody>
+      </p:sp>
+      <p:pic>
+        <p:nvPicPr>
+          <p:cNvPr id="7" name="Picture 6" descr="image.png"/>
+          <p:cNvPicPr>
+            <a:picLocks noChangeAspect="1"/>
+          </p:cNvPicPr>
+          <p:nvPr/>
+        </p:nvPicPr>
+        <p:blipFill>
+          <a:blip r:embed="rId2"/>
+          <a:stretch>
+            <a:fillRect/>
+          </a:stretch>
+        </p:blipFill>
+        <p:spPr>
+          <a:xfrm>
+            <a:off x="2009463" y="1325880"/>
+            <a:ext cx="8170026" cy="4937760"/>
+          </a:xfrm>
+          <a:prstGeom prst="rect">
+            <a:avLst/>
+          </a:prstGeom>
+        </p:spPr>
+      </p:pic>
+      <p:sp>
+        <p:nvSpPr>
+          <p:cNvPr id="8" name="Rectangle 7"/>
+          <p:cNvSpPr/>
+          <p:nvPr/>
+        </p:nvSpPr>
+        <p:spPr>
+          <a:xfrm>
+            <a:off x="0" y="6510528"/>
+            <a:ext cx="12188952" cy="347472"/>
+          </a:xfrm>
+          <a:prstGeom prst="rect">
+            <a:avLst/>
+          </a:prstGeom>
+          <a:solidFill>
+            <a:srgbClr val="0A1937"/>
+          </a:solidFill>
+          <a:ln>
+            <a:noFill/>
+          </a:ln>
+        </p:spPr>
+        <p:style>
+          <a:lnRef idx="1">
+            <a:schemeClr val="accent1"/>
+          </a:lnRef>
+          <a:fillRef idx="3">
+            <a:schemeClr val="accent1"/>
+          </a:fillRef>
+          <a:effectRef idx="2">
+            <a:schemeClr val="accent1"/>
+          </a:effectRef>
+          <a:fontRef idx="minor">
+            <a:schemeClr val="lt1"/>
+          </a:fontRef>
+        </p:style>
+        <p:txBody>
+          <a:bodyPr rtlCol="0" anchor="ctr"/>
+          <a:lstStyle/>
+          <a:p>
+            <a:pPr algn="ctr"/>
+          </a:p>
+        </p:txBody>
+      </p:sp>
+      <p:sp>
+        <p:nvSpPr>
+          <p:cNvPr id="9" name="TextBox 8"/>
+          <p:cNvSpPr txBox="1"/>
+          <p:nvPr/>
+        </p:nvSpPr>
+        <p:spPr>
+          <a:xfrm>
+            <a:off x="685800" y="6583680"/>
+            <a:ext cx="6490411" cy="256032"/>
+          </a:xfrm>
+          <a:prstGeom prst="rect">
+            <a:avLst/>
+          </a:prstGeom>
+          <a:noFill/>
+        </p:spPr>
+        <p:txBody>
+          <a:bodyPr wrap="none">
+            <a:spAutoFit/>
+          </a:bodyPr>
+          <a:lstStyle/>
+          <a:p>
+            <a:pPr algn="l"/>
+            <a:r>
+              <a:rPr sz="700">
+                <a:solidFill>
+                  <a:srgbClr val="A0B4D2"/>
+                </a:solidFill>
+                <a:latin typeface="Consolas"/>
+              </a:rPr>
+              <a:t>FKB Campus  ·  VA06</a:t>
+            </a:r>
+          </a:p>
+        </p:txBody>
+      </p:sp>
+      <p:sp>
+        <p:nvSpPr>
+          <p:cNvPr id="10" name="TextBox 9"/>
+          <p:cNvSpPr txBox="1"/>
+          <p:nvPr/>
+        </p:nvSpPr>
+        <p:spPr>
+          <a:xfrm>
+            <a:off x="7176211" y="6583680"/>
+            <a:ext cx="4326940" cy="256032"/>
+          </a:xfrm>
+          <a:prstGeom prst="rect">
+            <a:avLst/>
+          </a:prstGeom>
+          <a:noFill/>
+        </p:spPr>
+        <p:txBody>
+          <a:bodyPr wrap="none">
+            <a:spAutoFit/>
+          </a:bodyPr>
+          <a:lstStyle/>
+          <a:p>
+            <a:pPr algn="r"/>
+            <a:r>
+              <a:rPr sz="700">
+                <a:solidFill>
+                  <a:srgbClr val="A0B4D2"/>
+                </a:solidFill>
+                <a:latin typeface="Consolas"/>
+              </a:rPr>
+              <a:t>Schaubild</a:t>
+            </a:r>
+          </a:p>
+        </p:txBody>
+      </p:sp>
+    </p:spTree>
+  </p:cSld>
+  <p:clrMapOvr>
+    <a:masterClrMapping/>
+  </p:clrMapOvr>
+</p:sld>
+</file>
+
+<file path=ppt/slides/slide8.xml><?xml version="1.0" encoding="utf-8"?>
+<p:sld xmlns:a="http://schemas.openxmlformats.org/drawingml/2006/main" xmlns:p="http://schemas.openxmlformats.org/presentationml/2006/main" xmlns:r="http://schemas.openxmlformats.org/officeDocument/2006/relationships">
+  <p:cSld>
+    <p:spTree>
+      <p:nvGrpSpPr>
+        <p:cNvPr id="1" name=""/>
+        <p:cNvGrpSpPr/>
+        <p:nvPr/>
+      </p:nvGrpSpPr>
+      <p:grpSpPr/>
+      <p:sp>
+        <p:nvSpPr>
+          <p:cNvPr id="2" name="Rectangle 1"/>
+          <p:cNvSpPr/>
+          <p:nvPr/>
+        </p:nvSpPr>
+        <p:spPr>
+          <a:xfrm>
+            <a:off x="0" y="0"/>
+            <a:ext cx="12188952" cy="6858000"/>
+          </a:xfrm>
+          <a:prstGeom prst="rect">
+            <a:avLst/>
+          </a:prstGeom>
+          <a:solidFill>
+            <a:srgbClr val="EDEDF3"/>
+          </a:solidFill>
+          <a:ln>
+            <a:noFill/>
+          </a:ln>
+        </p:spPr>
+        <p:style>
+          <a:lnRef idx="1">
+            <a:schemeClr val="accent1"/>
+          </a:lnRef>
+          <a:fillRef idx="3">
+            <a:schemeClr val="accent1"/>
+          </a:fillRef>
+          <a:effectRef idx="2">
+            <a:schemeClr val="accent1"/>
+          </a:effectRef>
+          <a:fontRef idx="minor">
+            <a:schemeClr val="lt1"/>
+          </a:fontRef>
+        </p:style>
+        <p:txBody>
+          <a:bodyPr rtlCol="0" anchor="ctr"/>
+          <a:lstStyle/>
+          <a:p>
+            <a:pPr algn="ctr"/>
+          </a:p>
+        </p:txBody>
+      </p:sp>
+      <p:sp>
+        <p:nvSpPr>
+          <p:cNvPr id="3" name="Rectangle 2"/>
+          <p:cNvSpPr/>
+          <p:nvPr/>
+        </p:nvSpPr>
+        <p:spPr>
+          <a:xfrm>
+            <a:off x="0" y="0"/>
+            <a:ext cx="12188952" cy="50292"/>
+          </a:xfrm>
+          <a:prstGeom prst="rect">
+            <a:avLst/>
+          </a:prstGeom>
+          <a:solidFill>
+            <a:srgbClr val="1F2C56"/>
+          </a:solidFill>
+          <a:ln>
+            <a:noFill/>
+          </a:ln>
+        </p:spPr>
+        <p:style>
+          <a:lnRef idx="1">
+            <a:schemeClr val="accent1"/>
+          </a:lnRef>
+          <a:fillRef idx="3">
+            <a:schemeClr val="accent1"/>
+          </a:fillRef>
+          <a:effectRef idx="2">
+            <a:schemeClr val="accent1"/>
+          </a:effectRef>
+          <a:fontRef idx="minor">
+            <a:schemeClr val="lt1"/>
+          </a:fontRef>
+        </p:style>
+        <p:txBody>
+          <a:bodyPr rtlCol="0" anchor="ctr"/>
+          <a:lstStyle/>
+          <a:p>
+            <a:pPr algn="ctr"/>
+          </a:p>
+        </p:txBody>
+      </p:sp>
+      <p:sp>
+        <p:nvSpPr>
+          <p:cNvPr id="4" name="TextBox 3"/>
+          <p:cNvSpPr txBox="1"/>
+          <p:nvPr/>
+        </p:nvSpPr>
+        <p:spPr>
+          <a:xfrm>
+            <a:off x="685800" y="109728"/>
+            <a:ext cx="10817352" cy="228600"/>
+          </a:xfrm>
+          <a:prstGeom prst="rect">
+            <a:avLst/>
+          </a:prstGeom>
+          <a:noFill/>
+        </p:spPr>
+        <p:txBody>
+          <a:bodyPr wrap="none">
+            <a:spAutoFit/>
+          </a:bodyPr>
+          <a:lstStyle/>
+          <a:p>
+            <a:pPr algn="l"/>
+            <a:r>
+              <a:rPr sz="750">
+                <a:solidFill>
+                  <a:srgbClr val="78808C"/>
+                </a:solidFill>
+                <a:latin typeface="Consolas"/>
+              </a:rPr>
               <a:t>VA06  ·  INHALT</a:t>
             </a:r>
           </a:p>
@@ -6895,7 +9929,7 @@
                 </a:solidFill>
                 <a:latin typeface="Arial"/>
               </a:rPr>
-              <a:t>Reflexionsfragen</a:t>
+              <a:t>Was ist ein Anlass?</a:t>
             </a:r>
           </a:p>
         </p:txBody>
@@ -6917,10 +9951,48 @@
           <a:noFill/>
         </p:spPr>
         <p:txBody>
-          <a:bodyPr wrap="square" anchor="ctr">
+          <a:bodyPr wrap="square">
             <a:spAutoFit/>
           </a:bodyPr>
           <a:lstStyle/>
+          <a:p>
+            <a:pPr marL="177800" indent="-177800">
+              <a:spcBef>
+                <a:spcPts val="600"/>
+              </a:spcBef>
+              <a:spcAft>
+                <a:spcPts val="200"/>
+              </a:spcAft>
+            </a:pPr>
+            <a:r>
+              <a:rPr sz="1200" i="1">
+                <a:solidFill>
+                  <a:srgbClr val="3D5466"/>
+                </a:solidFill>
+                <a:latin typeface="Arial"/>
+              </a:rPr>
+              <a:t>→  Ein Anlass ist alles aus der Kundenhistorie, das der Berater im Gespräch ansprechen sollte – sichtbar markiert in den offenen Punkten.</a:t>
+            </a:r>
+          </a:p>
+          <a:p>
+            <a:pPr>
+              <a:spcBef>
+                <a:spcPts val="1000"/>
+              </a:spcBef>
+              <a:spcAft>
+                <a:spcPts val="200"/>
+              </a:spcAft>
+            </a:pPr>
+            <a:r>
+              <a:rPr sz="800" b="1">
+                <a:solidFill>
+                  <a:srgbClr val="78808C"/>
+                </a:solidFill>
+                <a:latin typeface="Consolas"/>
+              </a:rPr>
+              <a:t>DREI ANLASSTYPEN</a:t>
+            </a:r>
+          </a:p>
           <a:p>
             <a:pPr marL="190500" indent="-190500">
               <a:spcBef>
@@ -6937,7 +10009,7 @@
                 </a:solidFill>
                 <a:latin typeface="Arial"/>
               </a:rPr>
-              <a:t>▸  Woran merkt ein Berater, dass eine Terminmappe wirklich gut ist?</a:t>
+              <a:t>▸  Konkreter Handlungsbedarf – z. B. eine Zinsbindung läuft aus, die Prolongation steht an.</a:t>
             </a:r>
           </a:p>
           <a:p>
@@ -6956,7 +10028,7 @@
                 </a:solidFill>
                 <a:latin typeface="Arial"/>
               </a:rPr>
-              <a:t>▸  Welche Anlässe übersehen Sie in der Vorbereitung am ehesten?</a:t>
+              <a:t>▸  Kapazitätssignal – z. B. eine Linie ist zu 95 % ausgelastet; reicht das noch?</a:t>
             </a:r>
           </a:p>
           <a:p>
@@ -6975,7 +10047,26 @@
                 </a:solidFill>
                 <a:latin typeface="Arial"/>
               </a:rPr>
-              <a:t>▸  Was geht in Ihrer Praxis nach Terminen am häufigsten verloren – und warum?</a:t>
+              <a:t>▸  Andeutung des Kunden – z. B. „nächstes Jahr vielleicht eine Investition".</a:t>
+            </a:r>
+          </a:p>
+          <a:p>
+            <a:pPr marL="190500" indent="-190500">
+              <a:spcBef>
+                <a:spcPts val="400"/>
+              </a:spcBef>
+              <a:spcAft>
+                <a:spcPts val="200"/>
+              </a:spcAft>
+            </a:pPr>
+            <a:r>
+              <a:rPr sz="1300">
+                <a:solidFill>
+                  <a:srgbClr val="3D5466"/>
+                </a:solidFill>
+                <a:latin typeface="Arial"/>
+              </a:rPr>
+              <a:t>▸  Die Andeutung ist der wichtigste Typ: am fragilsten, weil sie verloren geht, wenn niemand sie festhält.</a:t>
             </a:r>
           </a:p>
         </p:txBody>
@@ -7050,6 +10141,250 @@
               <a:rPr sz="700">
                 <a:solidFill>
                   <a:srgbClr val="A0B4D2"/>
+                </a:solidFill>
+                <a:latin typeface="Consolas"/>
+              </a:rPr>
+              <a:t>FKB Campus  ·  VA06</a:t>
+            </a:r>
+          </a:p>
+        </p:txBody>
+      </p:sp>
+    </p:spTree>
+  </p:cSld>
+  <p:clrMapOvr>
+    <a:masterClrMapping/>
+  </p:clrMapOvr>
+</p:sld>
+</file>
+
+<file path=ppt/slides/slide9.xml><?xml version="1.0" encoding="utf-8"?>
+<p:sld xmlns:a="http://schemas.openxmlformats.org/drawingml/2006/main" xmlns:p="http://schemas.openxmlformats.org/presentationml/2006/main" xmlns:r="http://schemas.openxmlformats.org/officeDocument/2006/relationships">
+  <p:cSld>
+    <p:spTree>
+      <p:nvGrpSpPr>
+        <p:cNvPr id="1" name=""/>
+        <p:cNvGrpSpPr/>
+        <p:nvPr/>
+      </p:nvGrpSpPr>
+      <p:grpSpPr/>
+      <p:sp>
+        <p:nvSpPr>
+          <p:cNvPr id="2" name="Rectangle 1"/>
+          <p:cNvSpPr/>
+          <p:nvPr/>
+        </p:nvSpPr>
+        <p:spPr>
+          <a:xfrm>
+            <a:off x="0" y="0"/>
+            <a:ext cx="12188952" cy="6858000"/>
+          </a:xfrm>
+          <a:prstGeom prst="rect">
+            <a:avLst/>
+          </a:prstGeom>
+          <a:solidFill>
+            <a:srgbClr val="1F2C56"/>
+          </a:solidFill>
+          <a:ln>
+            <a:noFill/>
+          </a:ln>
+        </p:spPr>
+        <p:style>
+          <a:lnRef idx="1">
+            <a:schemeClr val="accent1"/>
+          </a:lnRef>
+          <a:fillRef idx="3">
+            <a:schemeClr val="accent1"/>
+          </a:fillRef>
+          <a:effectRef idx="2">
+            <a:schemeClr val="accent1"/>
+          </a:effectRef>
+          <a:fontRef idx="minor">
+            <a:schemeClr val="lt1"/>
+          </a:fontRef>
+        </p:style>
+        <p:txBody>
+          <a:bodyPr rtlCol="0" anchor="ctr"/>
+          <a:lstStyle/>
+          <a:p>
+            <a:pPr algn="ctr"/>
+          </a:p>
+        </p:txBody>
+      </p:sp>
+      <p:sp>
+        <p:nvSpPr>
+          <p:cNvPr id="3" name="TextBox 2"/>
+          <p:cNvSpPr txBox="1"/>
+          <p:nvPr/>
+        </p:nvSpPr>
+        <p:spPr>
+          <a:xfrm>
+            <a:off x="685800" y="2377440"/>
+            <a:ext cx="10817352" cy="365760"/>
+          </a:xfrm>
+          <a:prstGeom prst="rect">
+            <a:avLst/>
+          </a:prstGeom>
+          <a:noFill/>
+        </p:spPr>
+        <p:txBody>
+          <a:bodyPr wrap="none">
+            <a:spAutoFit/>
+          </a:bodyPr>
+          <a:lstStyle/>
+          <a:p>
+            <a:pPr algn="l"/>
+            <a:r>
+              <a:rPr sz="1200">
+                <a:solidFill>
+                  <a:srgbClr val="D9C089"/>
+                </a:solidFill>
+                <a:latin typeface="Consolas"/>
+              </a:rPr>
+              <a:t>00:15–01:10</a:t>
+            </a:r>
+          </a:p>
+        </p:txBody>
+      </p:sp>
+      <p:sp>
+        <p:nvSpPr>
+          <p:cNvPr id="4" name="Rectangle 3"/>
+          <p:cNvSpPr/>
+          <p:nvPr/>
+        </p:nvSpPr>
+        <p:spPr>
+          <a:xfrm>
+            <a:off x="685800" y="2788920"/>
+            <a:ext cx="548640" cy="38100"/>
+          </a:xfrm>
+          <a:prstGeom prst="rect">
+            <a:avLst/>
+          </a:prstGeom>
+          <a:solidFill>
+            <a:srgbClr val="D9C089"/>
+          </a:solidFill>
+          <a:ln>
+            <a:noFill/>
+          </a:ln>
+        </p:spPr>
+        <p:style>
+          <a:lnRef idx="1">
+            <a:schemeClr val="accent1"/>
+          </a:lnRef>
+          <a:fillRef idx="3">
+            <a:schemeClr val="accent1"/>
+          </a:fillRef>
+          <a:effectRef idx="2">
+            <a:schemeClr val="accent1"/>
+          </a:effectRef>
+          <a:fontRef idx="minor">
+            <a:schemeClr val="lt1"/>
+          </a:fontRef>
+        </p:style>
+        <p:txBody>
+          <a:bodyPr rtlCol="0" anchor="ctr"/>
+          <a:lstStyle/>
+          <a:p>
+            <a:pPr algn="ctr"/>
+          </a:p>
+        </p:txBody>
+      </p:sp>
+      <p:sp>
+        <p:nvSpPr>
+          <p:cNvPr id="5" name="TextBox 4"/>
+          <p:cNvSpPr txBox="1"/>
+          <p:nvPr/>
+        </p:nvSpPr>
+        <p:spPr>
+          <a:xfrm>
+            <a:off x="685800" y="3017520"/>
+            <a:ext cx="10817352" cy="1463040"/>
+          </a:xfrm>
+          <a:prstGeom prst="rect">
+            <a:avLst/>
+          </a:prstGeom>
+          <a:noFill/>
+        </p:spPr>
+        <p:txBody>
+          <a:bodyPr wrap="square">
+            <a:spAutoFit/>
+          </a:bodyPr>
+          <a:lstStyle/>
+          <a:p>
+            <a:pPr algn="l"/>
+            <a:r>
+              <a:rPr sz="4000" b="1" i="0">
+                <a:solidFill>
+                  <a:srgbClr val="FFFFFF"/>
+                </a:solidFill>
+                <a:latin typeface="Arial"/>
+              </a:rPr>
+              <a:t>Fallübergabe &amp; Fallarbeit</a:t>
+            </a:r>
+          </a:p>
+        </p:txBody>
+      </p:sp>
+      <p:sp>
+        <p:nvSpPr>
+          <p:cNvPr id="6" name="TextBox 5"/>
+          <p:cNvSpPr txBox="1"/>
+          <p:nvPr/>
+        </p:nvSpPr>
+        <p:spPr>
+          <a:xfrm>
+            <a:off x="685800" y="4480560"/>
+            <a:ext cx="8653881" cy="1280160"/>
+          </a:xfrm>
+          <a:prstGeom prst="rect">
+            <a:avLst/>
+          </a:prstGeom>
+          <a:noFill/>
+        </p:spPr>
+        <p:txBody>
+          <a:bodyPr wrap="square">
+            <a:spAutoFit/>
+          </a:bodyPr>
+          <a:lstStyle/>
+          <a:p>
+            <a:pPr algn="l"/>
+            <a:r>
+              <a:rPr sz="1600" b="0" i="0">
+                <a:solidFill>
+                  <a:srgbClr val="C8D2E6"/>
+                </a:solidFill>
+                <a:latin typeface="Arial"/>
+              </a:rPr>
+              <a:t>Jahresgespräch Handwerk Musterregion in zwei Tagen – bauen Sie die Terminmappe.</a:t>
+            </a:r>
+          </a:p>
+        </p:txBody>
+      </p:sp>
+      <p:sp>
+        <p:nvSpPr>
+          <p:cNvPr id="7" name="TextBox 6"/>
+          <p:cNvSpPr txBox="1"/>
+          <p:nvPr/>
+        </p:nvSpPr>
+        <p:spPr>
+          <a:xfrm>
+            <a:off x="685800" y="6355080"/>
+            <a:ext cx="10817352" cy="274320"/>
+          </a:xfrm>
+          <a:prstGeom prst="rect">
+            <a:avLst/>
+          </a:prstGeom>
+          <a:noFill/>
+        </p:spPr>
+        <p:txBody>
+          <a:bodyPr wrap="none">
+            <a:spAutoFit/>
+          </a:bodyPr>
+          <a:lstStyle/>
+          <a:p>
+            <a:pPr algn="l"/>
+            <a:r>
+              <a:rPr sz="700">
+                <a:solidFill>
+                  <a:srgbClr val="8CA0C3"/>
                 </a:solidFill>
                 <a:latin typeface="Consolas"/>
               </a:rPr>

</xml_diff>